<commit_message>
Update XMSS presentation with 5 new slides on pqSNARK aggregation
Co-Authored-By: Claude Sonnet 4.6 <noreply@anthropic.com>
</commit_message>
<xml_diff>
--- a/XMSS_Post_Cuantica_posta.pptx
+++ b/XMSS_Post_Cuantica_posta.pptx
@@ -23,6 +23,11 @@
     <p:sldId id="266" r:id="rId12"/>
     <p:sldId id="267" r:id="rId13"/>
     <p:sldId id="268" r:id="rId14"/>
+    <p:sldId id="275" r:id="rId26"/>
+    <p:sldId id="276" r:id="rId27"/>
+    <p:sldId id="277" r:id="rId28"/>
+    <p:sldId id="278" r:id="rId29"/>
+    <p:sldId id="279" r:id="rId30"/>
     <p:sldId id="269" r:id="rId15"/>
   </p:sldIdLst>
   <p:notesMasterIdLst>
@@ -6161,6 +6166,70 @@
           </a:p>
         </p:txBody>
       </p:sp>
+      <p:sp>
+        <p:nvSpPr>
+          <p:cNvPr id="99" name="RefBox"/>
+          <p:cNvSpPr/>
+          <p:nvPr/>
+        </p:nvSpPr>
+        <p:spPr>
+          <a:xfrm>
+            <a:off x="365760" y="4800600"/>
+            <a:ext cx="8412480" cy="274320"/>
+          </a:xfrm>
+          <a:prstGeom prst="rect">
+            <a:avLst/>
+          </a:prstGeom>
+          <a:solidFill>
+            <a:srgbClr val="10B981">
+              <a:alpha val="12000"/>
+            </a:srgbClr>
+          </a:solidFill>
+          <a:ln w="12700">
+            <a:solidFill>
+              <a:srgbClr val="10B981">
+                <a:alpha val="40000"/>
+              </a:srgbClr>
+            </a:solidFill>
+            <a:prstDash val="solid"/>
+          </a:ln>
+        </p:spPr>
+      </p:sp>
+      <p:sp>
+        <p:nvSpPr>
+          <p:cNvPr id="100" name="RefText"/>
+          <p:cNvSpPr/>
+          <p:nvPr/>
+        </p:nvSpPr>
+        <p:spPr>
+          <a:xfrm>
+            <a:off x="502920" y="4800600"/>
+            <a:ext cx="8138160" cy="274320"/>
+          </a:xfrm>
+          <a:prstGeom prst="rect">
+            <a:avLst/>
+          </a:prstGeom>
+          <a:noFill/>
+          <a:ln/>
+        </p:spPr>
+        <p:txBody>
+          <a:bodyPr wrap="square" lIns="91440" tIns="0" rIns="91440" bIns="0" rtlCol="0" anchor="ctr"/>
+          <a:lstStyle/>
+          <a:p>
+            <a:pPr indent="0" marL="0">
+              <a:buNone/>
+            </a:pPr>
+            <a:r>
+              <a:rPr lang="en-US" sz="900" i="1" dirty="0">
+                <a:solidFill>
+                  <a:srgbClr val="10B981"/>
+                </a:solidFill>
+              </a:rPr>
+              <a:t>➡  Ver slide 23: Resultados concretos — firma individual ~2,22 KiB, agregable vía pqSNARK a 2-3 MB para miles de firmantes</a:t>
+            </a:r>
+          </a:p>
+        </p:txBody>
+      </p:sp>
     </p:spTree>
   </p:cSld>
   <p:clrMapOvr>
@@ -6853,6 +6922,70 @@
           </a:p>
         </p:txBody>
       </p:sp>
+      <p:sp>
+        <p:nvSpPr>
+          <p:cNvPr id="99" name="RefBox"/>
+          <p:cNvSpPr/>
+          <p:nvPr/>
+        </p:nvSpPr>
+        <p:spPr>
+          <a:xfrm>
+            <a:off x="365760" y="4800600"/>
+            <a:ext cx="8412480" cy="274320"/>
+          </a:xfrm>
+          <a:prstGeom prst="rect">
+            <a:avLst/>
+          </a:prstGeom>
+          <a:solidFill>
+            <a:srgbClr val="3B82F6">
+              <a:alpha val="12000"/>
+            </a:srgbClr>
+          </a:solidFill>
+          <a:ln w="12700">
+            <a:solidFill>
+              <a:srgbClr val="3B82F6">
+                <a:alpha val="40000"/>
+              </a:srgbClr>
+            </a:solidFill>
+            <a:prstDash val="solid"/>
+          </a:ln>
+        </p:spPr>
+      </p:sp>
+      <p:sp>
+        <p:nvSpPr>
+          <p:cNvPr id="100" name="RefText"/>
+          <p:cNvSpPr/>
+          <p:nvPr/>
+        </p:nvSpPr>
+        <p:spPr>
+          <a:xfrm>
+            <a:off x="502920" y="4800600"/>
+            <a:ext cx="8138160" cy="274320"/>
+          </a:xfrm>
+          <a:prstGeom prst="rect">
+            <a:avLst/>
+          </a:prstGeom>
+          <a:noFill/>
+          <a:ln/>
+        </p:spPr>
+        <p:txBody>
+          <a:bodyPr wrap="square" lIns="91440" tIns="0" rIns="91440" bIns="0" rtlCol="0" anchor="ctr"/>
+          <a:lstStyle/>
+          <a:p>
+            <a:pPr indent="0" marL="0">
+              <a:buNone/>
+            </a:pPr>
+            <a:r>
+              <a:rPr lang="en-US" sz="900" i="1" dirty="0">
+                <a:solidFill>
+                  <a:srgbClr val="3B82F6"/>
+                </a:solidFill>
+              </a:rPr>
+              <a:t>➡  Ver slides 19-23: Detalle del paper “Hash-Based Multi-Signatures for Post-Quantum Ethereum” (Drake et al., 2025)</a:t>
+            </a:r>
+          </a:p>
+        </p:txBody>
+      </p:sp>
     </p:spTree>
   </p:cSld>
   <p:clrMapOvr>
@@ -12282,6 +12415,70 @@
           </a:p>
         </p:txBody>
       </p:sp>
+      <p:sp>
+        <p:nvSpPr>
+          <p:cNvPr id="99" name="RefBox"/>
+          <p:cNvSpPr/>
+          <p:nvPr/>
+        </p:nvSpPr>
+        <p:spPr>
+          <a:xfrm>
+            <a:off x="365760" y="4800600"/>
+            <a:ext cx="8412480" cy="274320"/>
+          </a:xfrm>
+          <a:prstGeom prst="rect">
+            <a:avLst/>
+          </a:prstGeom>
+          <a:solidFill>
+            <a:srgbClr val="F5A623">
+              <a:alpha val="12000"/>
+            </a:srgbClr>
+          </a:solidFill>
+          <a:ln w="12700">
+            <a:solidFill>
+              <a:srgbClr val="F5A623">
+                <a:alpha val="40000"/>
+              </a:srgbClr>
+            </a:solidFill>
+            <a:prstDash val="solid"/>
+          </a:ln>
+        </p:spPr>
+      </p:sp>
+      <p:sp>
+        <p:nvSpPr>
+          <p:cNvPr id="100" name="RefText"/>
+          <p:cNvSpPr/>
+          <p:nvPr/>
+        </p:nvSpPr>
+        <p:spPr>
+          <a:xfrm>
+            <a:off x="502920" y="4800600"/>
+            <a:ext cx="8138160" cy="274320"/>
+          </a:xfrm>
+          <a:prstGeom prst="rect">
+            <a:avLst/>
+          </a:prstGeom>
+          <a:noFill/>
+          <a:ln/>
+        </p:spPr>
+        <p:txBody>
+          <a:bodyPr wrap="square" lIns="91440" tIns="0" rIns="91440" bIns="0" rtlCol="0" anchor="ctr"/>
+          <a:lstStyle/>
+          <a:p>
+            <a:pPr indent="0" marL="0">
+              <a:buNone/>
+            </a:pPr>
+            <a:r>
+              <a:rPr lang="en-US" sz="900" i="1" dirty="0">
+                <a:solidFill>
+                  <a:srgbClr val="F5A623"/>
+                </a:solidFill>
+              </a:rPr>
+              <a:t>➡  Ver slide 22: TSW propone w=2 con target fijo, eliminando el checksum y logrando circuito SNARK de tamaño fijo</a:t>
+            </a:r>
+          </a:p>
+        </p:txBody>
+      </p:sp>
     </p:spTree>
   </p:cSld>
   <p:clrMapOvr>
@@ -13173,6 +13370,3153 @@
 </p:sld>
 </file>
 
+<file path=ppt/slides/slide20.xml><?xml version="1.0" encoding="utf-8"?>
+<p:sld xmlns:a="http://schemas.openxmlformats.org/drawingml/2006/main" xmlns:r="http://schemas.openxmlformats.org/officeDocument/2006/relationships" xmlns:p="http://schemas.openxmlformats.org/presentationml/2006/main">
+  <p:cSld name="Slide 20">
+    <p:bg>
+      <p:bgPr>
+        <a:solidFill>
+          <a:srgbClr val="080E1A"/>
+        </a:solidFill>
+      </p:bgPr>
+    </p:bg>
+    <p:spTree>
+      <p:nvGrpSpPr>
+        <p:cNvPr id="1" name=""/>
+        <p:cNvGrpSpPr/>
+        <p:nvPr/>
+      </p:nvGrpSpPr>
+      <p:grpSpPr>
+        <a:xfrm>
+          <a:off x="0" y="0"/>
+          <a:ext cx="0" cy="0"/>
+          <a:chOff x="0" y="0"/>
+          <a:chExt cx="0" cy="0"/>
+        </a:xfrm>
+      </p:grpSpPr>
+      <p:sp>
+        <p:nvSpPr>
+          <p:cNvPr id="2" name="Shape 0"/>
+          <p:cNvSpPr/>
+          <p:nvPr/>
+        </p:nvSpPr>
+        <p:spPr>
+          <a:xfrm>
+            <a:off x="0" y="0"/>
+            <a:ext cx="9144000" cy="960120"/>
+          </a:xfrm>
+          <a:prstGeom prst="rect">
+            <a:avLst/>
+          </a:prstGeom>
+          <a:solidFill>
+            <a:srgbClr val="F5A623"/>
+          </a:solidFill>
+          <a:ln w="12700">
+            <a:solidFill>
+              <a:srgbClr val="333333"/>
+            </a:solidFill>
+            <a:prstDash val="solid"/>
+          </a:ln>
+        </p:spPr>
+      </p:sp>
+      <p:sp>
+        <p:nvSpPr>
+          <p:cNvPr id="3" name="Text 1"/>
+          <p:cNvSpPr/>
+          <p:nvPr/>
+        </p:nvSpPr>
+        <p:spPr>
+          <a:xfrm>
+            <a:off x="365760" y="182880"/>
+            <a:ext cx="8412480" cy="457200"/>
+          </a:xfrm>
+          <a:prstGeom prst="rect">
+            <a:avLst/>
+          </a:prstGeom>
+          <a:noFill/>
+          <a:ln/>
+        </p:spPr>
+        <p:txBody>
+          <a:bodyPr wrap="square" lIns="0" tIns="0" rIns="0" bIns="0" rtlCol="0" anchor="ctr"/>
+          <a:lstStyle/>
+          <a:p>
+            <a:pPr indent="0" marL="0">
+              <a:buNone/>
+            </a:pPr>
+            <a:r>
+              <a:rPr lang="en-US" sz="2600" b="1" dirty="0">
+                <a:solidFill>
+                  <a:srgbClr val="F8FAFC"/>
+                </a:solidFill>
+                <a:latin typeface="Arial" pitchFamily="34" charset="0"/>
+                <a:ea typeface="Arial" pitchFamily="34" charset="-122"/>
+                <a:cs typeface="Arial" pitchFamily="34" charset="-120"/>
+              </a:rPr>
+              <a:t>El problema: agregar firmas XMSS a escala</a:t>
+            </a:r>
+          </a:p>
+        </p:txBody>
+      </p:sp>
+      <p:sp>
+        <p:nvSpPr>
+          <p:cNvPr id="4" name="Text 2"/>
+          <p:cNvSpPr/>
+          <p:nvPr/>
+        </p:nvSpPr>
+        <p:spPr>
+          <a:xfrm>
+            <a:off x="365760" y="640080"/>
+            <a:ext cx="8412480" cy="274320"/>
+          </a:xfrm>
+          <a:prstGeom prst="rect">
+            <a:avLst/>
+          </a:prstGeom>
+          <a:noFill/>
+          <a:ln/>
+        </p:spPr>
+        <p:txBody>
+          <a:bodyPr wrap="square" lIns="0" tIns="0" rIns="0" bIns="0" rtlCol="0" anchor="ctr"/>
+          <a:lstStyle/>
+          <a:p>
+            <a:pPr indent="0" marL="0">
+              <a:buNone/>
+            </a:pPr>
+            <a:r>
+              <a:rPr lang="en-US" sz="1250" i="1" dirty="0">
+                <a:solidFill>
+                  <a:srgbClr val="BFDBFE"/>
+                </a:solidFill>
+              </a:rPr>
+              <a:t>El desafío central que enfrenta Lean Ethereum</a:t>
+            </a:r>
+          </a:p>
+        </p:txBody>
+      </p:sp>
+      <p:sp>
+        <p:nvSpPr>
+          <p:cNvPr id="5" name="Shape 3"/>
+          <p:cNvSpPr/>
+          <p:nvPr/>
+        </p:nvSpPr>
+        <p:spPr>
+          <a:xfrm>
+            <a:off x="365760" y="1097280"/>
+            <a:ext cx="4114800" cy="2743200"/>
+          </a:xfrm>
+          <a:prstGeom prst="rect">
+            <a:avLst/>
+          </a:prstGeom>
+          <a:solidFill>
+            <a:srgbClr val="0F1E3D"/>
+          </a:solidFill>
+          <a:ln w="19050">
+            <a:solidFill>
+              <a:srgbClr val="F5A623"/>
+            </a:solidFill>
+            <a:prstDash val="solid"/>
+          </a:ln>
+          <a:effectLst>
+            <a:outerShdw sx="100000" sy="100000" kx="0" ky="0" algn="bl" rotWithShape="0" blurRad="101600" dist="38100" dir="8100000">
+              <a:srgbClr val="000000">
+                <a:alpha val="30000"/>
+              </a:srgbClr>
+            </a:outerShdw>
+          </a:effectLst>
+        </p:spPr>
+      </p:sp>
+      <p:sp>
+        <p:nvSpPr>
+          <p:cNvPr id="6" name="Text 4"/>
+          <p:cNvSpPr/>
+          <p:nvPr/>
+        </p:nvSpPr>
+        <p:spPr>
+          <a:xfrm>
+            <a:off x="502920" y="1143000"/>
+            <a:ext cx="3886200" cy="2651760"/>
+          </a:xfrm>
+          <a:prstGeom prst="rect">
+            <a:avLst/>
+          </a:prstGeom>
+          <a:noFill/>
+          <a:ln/>
+        </p:spPr>
+        <p:txBody>
+          <a:bodyPr wrap="square" lIns="91440" tIns="45720" rIns="91440" bIns="45720" rtlCol="0" anchor="t"/>
+          <a:lstStyle/>
+          <a:p>
+            <a:pPr indent="0" marL="0">
+              <a:buNone/>
+            </a:pPr>
+            <a:r>
+              <a:rPr lang="en-US" sz="1200" b="1" dirty="0">
+                <a:solidFill>
+                  <a:srgbClr val="F5A623"/>
+                </a:solidFill>
+              </a:rPr>
+              <a:t>Con BLS (hoy):</a:t>
+            </a:r>
+          </a:p>
+          <a:p>
+            <a:pPr indent="0" marL="0">
+              <a:buNone/>
+            </a:pPr>
+            <a:r>
+              <a:rPr lang="en-US" sz="1050" dirty="0">
+                <a:solidFill>
+                  <a:srgbClr val="BFDBFE"/>
+                </a:solidFill>
+              </a:rPr>
+              <a:t xml:space="preserve">  • Agregar firmas = operación matemática simple</a:t>
+            </a:r>
+          </a:p>
+          <a:p>
+            <a:pPr indent="0" marL="0">
+              <a:buNone/>
+            </a:pPr>
+            <a:r>
+              <a:rPr lang="en-US" sz="1050" dirty="0">
+                <a:solidFill>
+                  <a:srgbClr val="BFDBFE"/>
+                </a:solidFill>
+              </a:rPr>
+              <a:t xml:space="preserve">  • 10.000 firmas → 1 firma compacta de ~96 bytes</a:t>
+            </a:r>
+          </a:p>
+          <a:p>
+            <a:pPr indent="0" marL="0">
+              <a:buNone/>
+            </a:pPr>
+            <a:r>
+              <a:rPr lang="en-US" sz="1050" dirty="0">
+                <a:solidFill>
+                  <a:srgbClr val="BFDBFE"/>
+                </a:solidFill>
+              </a:rPr>
+              <a:t xml:space="preserve">  • Tiempo: casi instantáneo</a:t>
+            </a:r>
+          </a:p>
+          <a:p>
+            <a:pPr indent="0" marL="0">
+              <a:buNone/>
+            </a:pPr>
+            <a:r>
+              <a:rPr lang="en-US" sz="600" dirty="0">
+                <a:solidFill>
+                  <a:srgbClr val="080E1A"/>
+                </a:solidFill>
+              </a:rPr>
+              <a:t xml:space="preserve"> </a:t>
+            </a:r>
+          </a:p>
+          <a:p>
+            <a:pPr indent="0" marL="0">
+              <a:buNone/>
+            </a:pPr>
+            <a:r>
+              <a:rPr lang="en-US" sz="1200" b="1" dirty="0">
+                <a:solidFill>
+                  <a:srgbClr val="F5A623"/>
+                </a:solidFill>
+              </a:rPr>
+              <a:t>Con XMSS (post-cuántico):</a:t>
+            </a:r>
+          </a:p>
+          <a:p>
+            <a:pPr indent="0" marL="0">
+              <a:buNone/>
+            </a:pPr>
+            <a:r>
+              <a:rPr lang="en-US" sz="1050" dirty="0">
+                <a:solidFill>
+                  <a:srgbClr val="BFDBFE"/>
+                </a:solidFill>
+              </a:rPr>
+              <a:t xml:space="preserve">  • No existe agregación algebraica nativa</a:t>
+            </a:r>
+          </a:p>
+          <a:p>
+            <a:pPr indent="0" marL="0">
+              <a:buNone/>
+            </a:pPr>
+            <a:r>
+              <a:rPr lang="en-US" sz="1050" dirty="0">
+                <a:solidFill>
+                  <a:srgbClr val="BFDBFE"/>
+                </a:solidFill>
+              </a:rPr>
+              <a:t xml:space="preserve">  • Cada firma pesa ~2-3 KB</a:t>
+            </a:r>
+          </a:p>
+          <a:p>
+            <a:pPr indent="0" marL="0">
+              <a:buNone/>
+            </a:pPr>
+            <a:r>
+              <a:rPr lang="en-US" sz="1050" dirty="0">
+                <a:solidFill>
+                  <a:srgbClr val="BFDBFE"/>
+                </a:solidFill>
+              </a:rPr>
+              <a:t xml:space="preserve">  • 10.000 validadores → ~22 GB sin agregar ❌</a:t>
+            </a:r>
+          </a:p>
+        </p:txBody>
+      </p:sp>
+      <p:sp>
+        <p:nvSpPr>
+          <p:cNvPr id="7" name="Shape 5"/>
+          <p:cNvSpPr/>
+          <p:nvPr/>
+        </p:nvSpPr>
+        <p:spPr>
+          <a:xfrm>
+            <a:off x="4663440" y="1097280"/>
+            <a:ext cx="4114800" cy="2743200"/>
+          </a:xfrm>
+          <a:prstGeom prst="rect">
+            <a:avLst/>
+          </a:prstGeom>
+          <a:solidFill>
+            <a:srgbClr val="0F1E3D"/>
+          </a:solidFill>
+          <a:ln w="19050">
+            <a:solidFill>
+              <a:srgbClr val="3B82F6"/>
+            </a:solidFill>
+            <a:prstDash val="solid"/>
+          </a:ln>
+          <a:effectLst>
+            <a:outerShdw sx="100000" sy="100000" kx="0" ky="0" algn="bl" rotWithShape="0" blurRad="101600" dist="38100" dir="8100000">
+              <a:srgbClr val="000000">
+                <a:alpha val="30000"/>
+              </a:srgbClr>
+            </a:outerShdw>
+          </a:effectLst>
+        </p:spPr>
+      </p:sp>
+      <p:sp>
+        <p:nvSpPr>
+          <p:cNvPr id="8" name="Text 6"/>
+          <p:cNvSpPr/>
+          <p:nvPr/>
+        </p:nvSpPr>
+        <p:spPr>
+          <a:xfrm>
+            <a:off x="4800600" y="1143000"/>
+            <a:ext cx="3886200" cy="2651760"/>
+          </a:xfrm>
+          <a:prstGeom prst="rect">
+            <a:avLst/>
+          </a:prstGeom>
+          <a:noFill/>
+          <a:ln/>
+        </p:spPr>
+        <p:txBody>
+          <a:bodyPr wrap="square" lIns="91440" tIns="45720" rIns="91440" bIns="45720" rtlCol="0" anchor="t"/>
+          <a:lstStyle/>
+          <a:p>
+            <a:pPr indent="0" marL="0">
+              <a:buNone/>
+            </a:pPr>
+            <a:r>
+              <a:rPr lang="en-US" sz="1200" b="1" dirty="0">
+                <a:solidFill>
+                  <a:srgbClr val="3B82F6"/>
+                </a:solidFill>
+              </a:rPr>
+              <a:t>Por qué importa</a:t>
+            </a:r>
+          </a:p>
+          <a:p>
+            <a:pPr indent="0" marL="0">
+              <a:buNone/>
+            </a:pPr>
+            <a:r>
+              <a:rPr lang="en-US" sz="600" dirty="0">
+                <a:solidFill>
+                  <a:srgbClr val="080E1A"/>
+                </a:solidFill>
+              </a:rPr>
+              <a:t xml:space="preserve"> </a:t>
+            </a:r>
+          </a:p>
+          <a:p>
+            <a:pPr indent="0" marL="0">
+              <a:buNone/>
+            </a:pPr>
+            <a:r>
+              <a:rPr lang="en-US" sz="1050" dirty="0">
+                <a:solidFill>
+                  <a:srgbClr val="BFDBFE"/>
+                </a:solidFill>
+              </a:rPr>
+              <a:t>En cada slot de 4 segundos, el proposer necesita incluir en el bloque los votos de miles de validadores.</a:t>
+            </a:r>
+          </a:p>
+          <a:p>
+            <a:pPr indent="0" marL="0">
+              <a:buNone/>
+            </a:pPr>
+            <a:r>
+              <a:rPr lang="en-US" sz="600" dirty="0">
+                <a:solidFill>
+                  <a:srgbClr val="080E1A"/>
+                </a:solidFill>
+              </a:rPr>
+              <a:t xml:space="preserve"> </a:t>
+            </a:r>
+          </a:p>
+          <a:p>
+            <a:pPr indent="0" marL="0">
+              <a:buNone/>
+            </a:pPr>
+            <a:r>
+              <a:rPr lang="en-US" sz="1050" dirty="0">
+                <a:solidFill>
+                  <a:srgbClr val="BFDBFE"/>
+                </a:solidFill>
+              </a:rPr>
+              <a:t>Con firmas de ese tamaño, sin una solución de agregación, el sistema es inviable.</a:t>
+            </a:r>
+          </a:p>
+        </p:txBody>
+      </p:sp>
+      <p:sp>
+        <p:nvSpPr>
+          <p:cNvPr id="9" name="Shape 7"/>
+          <p:cNvSpPr/>
+          <p:nvPr/>
+        </p:nvSpPr>
+        <p:spPr>
+          <a:xfrm>
+            <a:off x="365760" y="4023360"/>
+            <a:ext cx="8412480" cy="548640"/>
+          </a:xfrm>
+          <a:prstGeom prst="rect">
+            <a:avLst/>
+          </a:prstGeom>
+          <a:solidFill>
+            <a:srgbClr val="F5A623">
+              <a:alpha val="15000"/>
+            </a:srgbClr>
+          </a:solidFill>
+          <a:ln w="19050">
+            <a:solidFill>
+              <a:srgbClr val="F5A623"/>
+            </a:solidFill>
+            <a:prstDash val="solid"/>
+          </a:ln>
+        </p:spPr>
+      </p:sp>
+      <p:sp>
+        <p:nvSpPr>
+          <p:cNvPr id="10" name="Text 8"/>
+          <p:cNvSpPr/>
+          <p:nvPr/>
+        </p:nvSpPr>
+        <p:spPr>
+          <a:xfrm>
+            <a:off x="502920" y="4023360"/>
+            <a:ext cx="8138160" cy="548640"/>
+          </a:xfrm>
+          <a:prstGeom prst="rect">
+            <a:avLst/>
+          </a:prstGeom>
+          <a:noFill/>
+          <a:ln/>
+        </p:spPr>
+        <p:txBody>
+          <a:bodyPr wrap="square" lIns="91440" tIns="45720" rIns="91440" bIns="45720" rtlCol="0" anchor="ctr"/>
+          <a:lstStyle/>
+          <a:p>
+            <a:pPr indent="0" marL="0">
+              <a:buNone/>
+            </a:pPr>
+            <a:r>
+              <a:rPr lang="en-US" sz="1050" dirty="0">
+                <a:solidFill>
+                  <a:srgbClr val="F5A623"/>
+                </a:solidFill>
+              </a:rPr>
+              <a:t>⚠  La solución no puede usar álgebra de curvas elípticas — eso rompería la resistencia cuántica. Necesita una alternativa basada en hash.</a:t>
+            </a:r>
+          </a:p>
+        </p:txBody>
+      </p:sp>
+    </p:spTree>
+  </p:cSld>
+  <p:clrMapOvr>
+    <a:masterClrMapping/>
+  </p:clrMapOvr>
+</p:sld>
+</file>
+
+<file path=ppt/slides/slide21.xml><?xml version="1.0" encoding="utf-8"?>
+<p:sld xmlns:a="http://schemas.openxmlformats.org/drawingml/2006/main" xmlns:r="http://schemas.openxmlformats.org/officeDocument/2006/relationships" xmlns:p="http://schemas.openxmlformats.org/presentationml/2006/main">
+  <p:cSld name="Slide 21">
+    <p:bg>
+      <p:bgPr>
+        <a:solidFill>
+          <a:srgbClr val="080E1A"/>
+        </a:solidFill>
+      </p:bgPr>
+    </p:bg>
+    <p:spTree>
+      <p:nvGrpSpPr>
+        <p:cNvPr id="1" name=""/>
+        <p:cNvGrpSpPr/>
+        <p:nvPr/>
+      </p:nvGrpSpPr>
+      <p:grpSpPr>
+        <a:xfrm>
+          <a:off x="0" y="0"/>
+          <a:ext cx="0" cy="0"/>
+          <a:chOff x="0" y="0"/>
+          <a:chExt cx="0" cy="0"/>
+        </a:xfrm>
+      </p:grpSpPr>
+      <p:sp>
+        <p:nvSpPr>
+          <p:cNvPr id="2" name="Shape 0"/>
+          <p:cNvSpPr/>
+          <p:nvPr/>
+        </p:nvSpPr>
+        <p:spPr>
+          <a:xfrm>
+            <a:off x="0" y="0"/>
+            <a:ext cx="9144000" cy="960120"/>
+          </a:xfrm>
+          <a:prstGeom prst="rect">
+            <a:avLst/>
+          </a:prstGeom>
+          <a:solidFill>
+            <a:srgbClr val="065F46"/>
+          </a:solidFill>
+          <a:ln w="12700">
+            <a:solidFill>
+              <a:srgbClr val="333333"/>
+            </a:solidFill>
+            <a:prstDash val="solid"/>
+          </a:ln>
+        </p:spPr>
+      </p:sp>
+      <p:sp>
+        <p:nvSpPr>
+          <p:cNvPr id="3" name="Text 1"/>
+          <p:cNvSpPr/>
+          <p:nvPr/>
+        </p:nvSpPr>
+        <p:spPr>
+          <a:xfrm>
+            <a:off x="365760" y="182880"/>
+            <a:ext cx="8412480" cy="457200"/>
+          </a:xfrm>
+          <a:prstGeom prst="rect">
+            <a:avLst/>
+          </a:prstGeom>
+          <a:noFill/>
+          <a:ln/>
+        </p:spPr>
+        <p:txBody>
+          <a:bodyPr wrap="square" lIns="0" tIns="0" rIns="0" bIns="0" rtlCol="0" anchor="ctr"/>
+          <a:lstStyle/>
+          <a:p>
+            <a:pPr indent="0" marL="0">
+              <a:buNone/>
+            </a:pPr>
+            <a:r>
+              <a:rPr lang="en-US" sz="2600" b="1" dirty="0">
+                <a:solidFill>
+                  <a:srgbClr val="F8FAFC"/>
+                </a:solidFill>
+                <a:latin typeface="Arial" pitchFamily="34" charset="0"/>
+                <a:ea typeface="Arial" pitchFamily="34" charset="-122"/>
+                <a:cs typeface="Arial" pitchFamily="34" charset="-120"/>
+              </a:rPr>
+              <a:t>La solución: pqSNARK para agregación</a:t>
+            </a:r>
+          </a:p>
+        </p:txBody>
+      </p:sp>
+      <p:sp>
+        <p:nvSpPr>
+          <p:cNvPr id="4" name="Text 2"/>
+          <p:cNvSpPr/>
+          <p:nvPr/>
+        </p:nvSpPr>
+        <p:spPr>
+          <a:xfrm>
+            <a:off x="365760" y="640080"/>
+            <a:ext cx="8412480" cy="274320"/>
+          </a:xfrm>
+          <a:prstGeom prst="rect">
+            <a:avLst/>
+          </a:prstGeom>
+          <a:noFill/>
+          <a:ln/>
+        </p:spPr>
+        <p:txBody>
+          <a:bodyPr wrap="square" lIns="0" tIns="0" rIns="0" bIns="0" rtlCol="0" anchor="ctr"/>
+          <a:lstStyle/>
+          <a:p>
+            <a:pPr indent="0" marL="0">
+              <a:buNone/>
+            </a:pPr>
+            <a:r>
+              <a:rPr lang="en-US" sz="1250" i="1" dirty="0">
+                <a:solidFill>
+                  <a:srgbClr val="BFDBFE"/>
+                </a:solidFill>
+              </a:rPr>
+              <a:t>Pruebas sucintas post-cuánticas como reemplazo de la agregación BLS</a:t>
+            </a:r>
+          </a:p>
+        </p:txBody>
+      </p:sp>
+      <p:sp>
+        <p:nvSpPr>
+          <p:cNvPr id="5" name="Shape 3"/>
+          <p:cNvSpPr/>
+          <p:nvPr/>
+        </p:nvSpPr>
+        <p:spPr>
+          <a:xfrm>
+            <a:off x="365760" y="1097280"/>
+            <a:ext cx="4114800" cy="1280160"/>
+          </a:xfrm>
+          <a:prstGeom prst="rect">
+            <a:avLst/>
+          </a:prstGeom>
+          <a:solidFill>
+            <a:srgbClr val="0F1E3D"/>
+          </a:solidFill>
+          <a:ln w="19050">
+            <a:solidFill>
+              <a:srgbClr val="10B981"/>
+            </a:solidFill>
+            <a:prstDash val="solid"/>
+          </a:ln>
+          <a:effectLst>
+            <a:outerShdw sx="100000" sy="100000" kx="0" ky="0" algn="bl" rotWithShape="0" blurRad="101600" dist="38100" dir="8100000">
+              <a:srgbClr val="000000">
+                <a:alpha val="30000"/>
+              </a:srgbClr>
+            </a:outerShdw>
+          </a:effectLst>
+        </p:spPr>
+      </p:sp>
+      <p:sp>
+        <p:nvSpPr>
+          <p:cNvPr id="6" name="Text 4"/>
+          <p:cNvSpPr/>
+          <p:nvPr/>
+        </p:nvSpPr>
+        <p:spPr>
+          <a:xfrm>
+            <a:off x="502920" y="1143000"/>
+            <a:ext cx="3886200" cy="1188720"/>
+          </a:xfrm>
+          <a:prstGeom prst="rect">
+            <a:avLst/>
+          </a:prstGeom>
+          <a:noFill/>
+          <a:ln/>
+        </p:spPr>
+        <p:txBody>
+          <a:bodyPr wrap="square" lIns="91440" tIns="45720" rIns="91440" bIns="45720" rtlCol="0" anchor="t"/>
+          <a:lstStyle/>
+          <a:p>
+            <a:pPr indent="0" marL="0">
+              <a:buNone/>
+            </a:pPr>
+            <a:r>
+              <a:rPr lang="en-US" sz="1200" b="1" dirty="0">
+                <a:solidFill>
+                  <a:srgbClr val="10B981"/>
+                </a:solidFill>
+              </a:rPr>
+              <a:t>¿Qué es un pqSNARK?</a:t>
+            </a:r>
+          </a:p>
+          <a:p>
+            <a:pPr indent="0" marL="0">
+              <a:buNone/>
+            </a:pPr>
+            <a:r>
+              <a:rPr lang="en-US" sz="400" dirty="0">
+                <a:solidFill>
+                  <a:srgbClr val="080E1A"/>
+                </a:solidFill>
+              </a:rPr>
+              <a:t xml:space="preserve"> </a:t>
+            </a:r>
+          </a:p>
+          <a:p>
+            <a:pPr indent="0" marL="0">
+              <a:buNone/>
+            </a:pPr>
+            <a:r>
+              <a:rPr lang="en-US" sz="1050" dirty="0">
+                <a:solidFill>
+                  <a:srgbClr val="BFDBFE"/>
+                </a:solidFill>
+              </a:rPr>
+              <a:t>Una prueba criptográfica que demuestra que se ejecutó un programa correctamente, sin revelar los inputs. Es muy pequeña y rápida de verificar. La “pq” significa que también es resistente a computadoras cuánticas.</a:t>
+            </a:r>
+          </a:p>
+        </p:txBody>
+      </p:sp>
+      <p:sp>
+        <p:nvSpPr>
+          <p:cNvPr id="7" name="Shape 5"/>
+          <p:cNvSpPr/>
+          <p:nvPr/>
+        </p:nvSpPr>
+        <p:spPr>
+          <a:xfrm>
+            <a:off x="4663440" y="1097280"/>
+            <a:ext cx="4114800" cy="1280160"/>
+          </a:xfrm>
+          <a:prstGeom prst="rect">
+            <a:avLst/>
+          </a:prstGeom>
+          <a:solidFill>
+            <a:srgbClr val="0F1E3D"/>
+          </a:solidFill>
+          <a:ln w="19050">
+            <a:solidFill>
+              <a:srgbClr val="3B82F6"/>
+            </a:solidFill>
+            <a:prstDash val="solid"/>
+          </a:ln>
+          <a:effectLst>
+            <a:outerShdw sx="100000" sy="100000" kx="0" ky="0" algn="bl" rotWithShape="0" blurRad="101600" dist="38100" dir="8100000">
+              <a:srgbClr val="000000">
+                <a:alpha val="30000"/>
+              </a:srgbClr>
+            </a:outerShdw>
+          </a:effectLst>
+        </p:spPr>
+      </p:sp>
+      <p:sp>
+        <p:nvSpPr>
+          <p:cNvPr id="8" name="Text 6"/>
+          <p:cNvSpPr/>
+          <p:nvPr/>
+        </p:nvSpPr>
+        <p:spPr>
+          <a:xfrm>
+            <a:off x="4800600" y="1143000"/>
+            <a:ext cx="3886200" cy="1188720"/>
+          </a:xfrm>
+          <a:prstGeom prst="rect">
+            <a:avLst/>
+          </a:prstGeom>
+          <a:noFill/>
+          <a:ln/>
+        </p:spPr>
+        <p:txBody>
+          <a:bodyPr wrap="square" lIns="91440" tIns="45720" rIns="91440" bIns="45720" rtlCol="0" anchor="t"/>
+          <a:lstStyle/>
+          <a:p>
+            <a:pPr indent="0" marL="0">
+              <a:buNone/>
+            </a:pPr>
+            <a:r>
+              <a:rPr lang="en-US" sz="1200" b="1" dirty="0">
+                <a:solidFill>
+                  <a:srgbClr val="3B82F6"/>
+                </a:solidFill>
+              </a:rPr>
+              <a:t>El flujo de agregación</a:t>
+            </a:r>
+          </a:p>
+          <a:p>
+            <a:pPr indent="0" marL="0">
+              <a:buNone/>
+            </a:pPr>
+            <a:r>
+              <a:rPr lang="en-US" sz="400" dirty="0">
+                <a:solidFill>
+                  <a:srgbClr val="080E1A"/>
+                </a:solidFill>
+              </a:rPr>
+              <a:t xml:space="preserve"> </a:t>
+            </a:r>
+          </a:p>
+          <a:p>
+            <a:pPr indent="0" marL="0">
+              <a:buNone/>
+            </a:pPr>
+            <a:r>
+              <a:rPr lang="en-US" sz="1050" dirty="0">
+                <a:solidFill>
+                  <a:srgbClr val="BFDBFE"/>
+                </a:solidFill>
+              </a:rPr>
+              <a:t>1. Cada validador firma con su XMSS</a:t>
+            </a:r>
+          </a:p>
+          <a:p>
+            <a:pPr indent="0" marL="0">
+              <a:buNone/>
+            </a:pPr>
+            <a:r>
+              <a:rPr lang="en-US" sz="1050" dirty="0">
+                <a:solidFill>
+                  <a:srgbClr val="BFDBFE"/>
+                </a:solidFill>
+              </a:rPr>
+              <a:t>2. El Aggregator genera un pqSNARK</a:t>
+            </a:r>
+          </a:p>
+          <a:p>
+            <a:pPr indent="0" marL="0">
+              <a:buNone/>
+            </a:pPr>
+            <a:r>
+              <a:rPr lang="en-US" sz="1050" dirty="0">
+                <a:solidFill>
+                  <a:srgbClr val="BFDBFE"/>
+                </a:solidFill>
+              </a:rPr>
+              <a:t>3. Firma agregada = argumento SNARK</a:t>
+            </a:r>
+          </a:p>
+          <a:p>
+            <a:pPr indent="0" marL="0">
+              <a:buNone/>
+            </a:pPr>
+            <a:r>
+              <a:rPr lang="en-US" sz="1050" dirty="0">
+                <a:solidFill>
+                  <a:srgbClr val="BFDBFE"/>
+                </a:solidFill>
+              </a:rPr>
+              <a:t>4. Verificar = correr el verificador (rápido)</a:t>
+            </a:r>
+          </a:p>
+        </p:txBody>
+      </p:sp>
+      <p:sp>
+        <p:nvSpPr>
+          <p:cNvPr id="20" name="Shape 20"/>
+          <p:cNvSpPr/>
+          <p:nvPr/>
+        </p:nvSpPr>
+        <p:spPr>
+          <a:xfrm>
+            <a:off x="365760" y="2560320"/>
+            <a:ext cx="8412480" cy="320040"/>
+          </a:xfrm>
+          <a:prstGeom prst="rect">
+            <a:avLst/>
+          </a:prstGeom>
+          <a:solidFill>
+            <a:srgbClr val="162D50"/>
+          </a:solidFill>
+          <a:ln w="12700">
+            <a:solidFill>
+              <a:srgbClr val="1E3A5F"/>
+            </a:solidFill>
+            <a:prstDash val="solid"/>
+          </a:ln>
+        </p:spPr>
+      </p:sp>
+      <p:sp>
+        <p:nvSpPr>
+          <p:cNvPr id="21" name="Text 21"/>
+          <p:cNvSpPr/>
+          <p:nvPr/>
+        </p:nvSpPr>
+        <p:spPr>
+          <a:xfrm>
+            <a:off x="365760" y="2560320"/>
+            <a:ext cx="8412480" cy="320040"/>
+          </a:xfrm>
+          <a:prstGeom prst="rect">
+            <a:avLst/>
+          </a:prstGeom>
+          <a:noFill/>
+          <a:ln/>
+        </p:spPr>
+        <p:txBody>
+          <a:bodyPr wrap="square" lIns="91440" tIns="0" rIns="91440" bIns="0" rtlCol="0" anchor="ctr"/>
+          <a:lstStyle/>
+          <a:p>
+            <a:pPr indent="0" marL="0">
+              <a:buNone/>
+            </a:pPr>
+            <a:r>
+              <a:rPr lang="en-US" sz="1000" b="1" dirty="0">
+                <a:solidFill>
+                  <a:srgbClr val="F8FAFC"/>
+                </a:solidFill>
+              </a:rPr>
+              <a:t xml:space="preserve">                                                        Sin agregar                                  Con pqSNARK</a:t>
+            </a:r>
+          </a:p>
+        </p:txBody>
+      </p:sp>
+      <p:sp>
+        <p:nvSpPr>
+          <p:cNvPr id="22" name="Shape 22"/>
+          <p:cNvSpPr/>
+          <p:nvPr/>
+        </p:nvSpPr>
+        <p:spPr>
+          <a:xfrm>
+            <a:off x="365760" y="2880360"/>
+            <a:ext cx="8412480" cy="822960"/>
+          </a:xfrm>
+          <a:prstGeom prst="rect">
+            <a:avLst/>
+          </a:prstGeom>
+          <a:solidFill>
+            <a:srgbClr val="0F1E3D"/>
+          </a:solidFill>
+          <a:ln w="12700">
+            <a:solidFill>
+              <a:srgbClr val="1E3A5F"/>
+            </a:solidFill>
+            <a:prstDash val="solid"/>
+          </a:ln>
+        </p:spPr>
+      </p:sp>
+      <p:sp>
+        <p:nvSpPr>
+          <p:cNvPr id="23" name="Text 23"/>
+          <p:cNvSpPr/>
+          <p:nvPr/>
+        </p:nvSpPr>
+        <p:spPr>
+          <a:xfrm>
+            <a:off x="365760" y="2880360"/>
+            <a:ext cx="8412480" cy="822960"/>
+          </a:xfrm>
+          <a:prstGeom prst="rect">
+            <a:avLst/>
+          </a:prstGeom>
+          <a:noFill/>
+          <a:ln/>
+        </p:spPr>
+        <p:txBody>
+          <a:bodyPr wrap="square" lIns="91440" tIns="45720" rIns="91440" bIns="45720" rtlCol="0" anchor="t"/>
+          <a:lstStyle/>
+          <a:p>
+            <a:pPr indent="0" marL="0">
+              <a:buNone/>
+            </a:pPr>
+            <a:r>
+              <a:rPr lang="en-US" sz="1000" b="1" dirty="0">
+                <a:solidFill>
+                  <a:srgbClr val="BFDBFE"/>
+                </a:solidFill>
+              </a:rPr>
+              <a:t xml:space="preserve">1.000 firmas         </a:t>
+            </a:r>
+            <a:r>
+              <a:rPr lang="en-US" sz="1000" dirty="0">
+                <a:solidFill>
+                  <a:srgbClr val="EF4444"/>
+                </a:solidFill>
+              </a:rPr>
+              <a:t xml:space="preserve">~2,2 GB                              </a:t>
+            </a:r>
+            <a:r>
+              <a:rPr lang="en-US" sz="1000" dirty="0">
+                <a:solidFill>
+                  <a:srgbClr val="10B981"/>
+                </a:solidFill>
+              </a:rPr>
+              <a:t>~2-3 MB</a:t>
+            </a:r>
+          </a:p>
+          <a:p>
+            <a:pPr indent="0" marL="0">
+              <a:buNone/>
+            </a:pPr>
+            <a:r>
+              <a:rPr lang="en-US" sz="1000" b="1" dirty="0">
+                <a:solidFill>
+                  <a:srgbClr val="BFDBFE"/>
+                </a:solidFill>
+              </a:rPr>
+              <a:t xml:space="preserve">10.000 firmas      </a:t>
+            </a:r>
+            <a:r>
+              <a:rPr lang="en-US" sz="1000" dirty="0">
+                <a:solidFill>
+                  <a:srgbClr val="EF4444"/>
+                </a:solidFill>
+              </a:rPr>
+              <a:t xml:space="preserve">~22 GB                               </a:t>
+            </a:r>
+            <a:r>
+              <a:rPr lang="en-US" sz="1000" dirty="0">
+                <a:solidFill>
+                  <a:srgbClr val="10B981"/>
+                </a:solidFill>
+              </a:rPr>
+              <a:t>~2-3 MB</a:t>
+            </a:r>
+          </a:p>
+          <a:p>
+            <a:pPr indent="0" marL="0">
+              <a:buNone/>
+            </a:pPr>
+            <a:r>
+              <a:rPr lang="en-US" sz="1000" b="1" dirty="0">
+                <a:solidFill>
+                  <a:srgbClr val="BFDBFE"/>
+                </a:solidFill>
+              </a:rPr>
+              <a:t xml:space="preserve">Verificación          </a:t>
+            </a:r>
+            <a:r>
+              <a:rPr lang="en-US" sz="1000" dirty="0">
+                <a:solidFill>
+                  <a:srgbClr val="EF4444"/>
+                </a:solidFill>
+              </a:rPr>
+              <a:t xml:space="preserve">k verificaciones                  </a:t>
+            </a:r>
+            <a:r>
+              <a:rPr lang="en-US" sz="1000" dirty="0">
+                <a:solidFill>
+                  <a:srgbClr val="10B981"/>
+                </a:solidFill>
+              </a:rPr>
+              <a:t>1 verificación</a:t>
+            </a:r>
+          </a:p>
+        </p:txBody>
+      </p:sp>
+      <p:sp>
+        <p:nvSpPr>
+          <p:cNvPr id="11" name="Shape 9"/>
+          <p:cNvSpPr/>
+          <p:nvPr/>
+        </p:nvSpPr>
+        <p:spPr>
+          <a:xfrm>
+            <a:off x="365760" y="4023360"/>
+            <a:ext cx="8412480" cy="548640"/>
+          </a:xfrm>
+          <a:prstGeom prst="rect">
+            <a:avLst/>
+          </a:prstGeom>
+          <a:solidFill>
+            <a:srgbClr val="10B981">
+              <a:alpha val="15000"/>
+            </a:srgbClr>
+          </a:solidFill>
+          <a:ln w="19050">
+            <a:solidFill>
+              <a:srgbClr val="10B981"/>
+            </a:solidFill>
+            <a:prstDash val="solid"/>
+          </a:ln>
+        </p:spPr>
+      </p:sp>
+      <p:sp>
+        <p:nvSpPr>
+          <p:cNvPr id="12" name="Text 10"/>
+          <p:cNvSpPr/>
+          <p:nvPr/>
+        </p:nvSpPr>
+        <p:spPr>
+          <a:xfrm>
+            <a:off x="502920" y="4023360"/>
+            <a:ext cx="8138160" cy="548640"/>
+          </a:xfrm>
+          <a:prstGeom prst="rect">
+            <a:avLst/>
+          </a:prstGeom>
+          <a:noFill/>
+          <a:ln/>
+        </p:spPr>
+        <p:txBody>
+          <a:bodyPr wrap="square" lIns="91440" tIns="45720" rIns="91440" bIns="45720" rtlCol="0" anchor="ctr"/>
+          <a:lstStyle/>
+          <a:p>
+            <a:pPr indent="0" marL="0">
+              <a:buNone/>
+            </a:pPr>
+            <a:r>
+              <a:rPr lang="en-US" sz="1050" dirty="0">
+                <a:solidFill>
+                  <a:srgbClr val="10B981"/>
+                </a:solidFill>
+              </a:rPr>
+              <a:t>✅  Con más de 1.000 firmantes, la firma agregada es más chica que cualquier firma individual. El tamaño del SNARK no crece con la cantidad de firmantes.</a:t>
+            </a:r>
+          </a:p>
+        </p:txBody>
+      </p:sp>
+    </p:spTree>
+  </p:cSld>
+  <p:clrMapOvr>
+    <a:masterClrMapping/>
+  </p:clrMapOvr>
+</p:sld>
+</file>
+
+<file path=ppt/slides/slide22.xml><?xml version="1.0" encoding="utf-8"?>
+<p:sld xmlns:a="http://schemas.openxmlformats.org/drawingml/2006/main" xmlns:r="http://schemas.openxmlformats.org/officeDocument/2006/relationships" xmlns:p="http://schemas.openxmlformats.org/presentationml/2006/main">
+  <p:cSld name="Slide 22">
+    <p:bg>
+      <p:bgPr>
+        <a:solidFill>
+          <a:srgbClr val="080E1A"/>
+        </a:solidFill>
+      </p:bgPr>
+    </p:bg>
+    <p:spTree>
+      <p:nvGrpSpPr>
+        <p:cNvPr id="1" name=""/>
+        <p:cNvGrpSpPr/>
+        <p:nvPr/>
+      </p:nvGrpSpPr>
+      <p:grpSpPr>
+        <a:xfrm>
+          <a:off x="0" y="0"/>
+          <a:ext cx="0" cy="0"/>
+          <a:chOff x="0" y="0"/>
+          <a:chExt cx="0" cy="0"/>
+        </a:xfrm>
+      </p:grpSpPr>
+      <p:sp>
+        <p:nvSpPr>
+          <p:cNvPr id="2" name="Shape 0"/>
+          <p:cNvSpPr/>
+          <p:nvPr/>
+        </p:nvSpPr>
+        <p:spPr>
+          <a:xfrm>
+            <a:off x="0" y="0"/>
+            <a:ext cx="9144000" cy="960120"/>
+          </a:xfrm>
+          <a:prstGeom prst="rect">
+            <a:avLst/>
+          </a:prstGeom>
+          <a:solidFill>
+            <a:srgbClr val="1E3A5F"/>
+          </a:solidFill>
+          <a:ln w="12700">
+            <a:solidFill>
+              <a:srgbClr val="333333"/>
+            </a:solidFill>
+            <a:prstDash val="solid"/>
+          </a:ln>
+        </p:spPr>
+      </p:sp>
+      <p:sp>
+        <p:nvSpPr>
+          <p:cNvPr id="3" name="Text 1"/>
+          <p:cNvSpPr/>
+          <p:nvPr/>
+        </p:nvSpPr>
+        <p:spPr>
+          <a:xfrm>
+            <a:off x="365760" y="182880"/>
+            <a:ext cx="8412480" cy="457200"/>
+          </a:xfrm>
+          <a:prstGeom prst="rect">
+            <a:avLst/>
+          </a:prstGeom>
+          <a:noFill/>
+          <a:ln/>
+        </p:spPr>
+        <p:txBody>
+          <a:bodyPr wrap="square" lIns="0" tIns="0" rIns="0" bIns="0" rtlCol="0" anchor="ctr"/>
+          <a:lstStyle/>
+          <a:p>
+            <a:pPr indent="0" marL="0">
+              <a:buNone/>
+            </a:pPr>
+            <a:r>
+              <a:rPr lang="en-US" sz="2600" b="1" dirty="0">
+                <a:solidFill>
+                  <a:srgbClr val="F8FAFC"/>
+                </a:solidFill>
+                <a:latin typeface="Arial" pitchFamily="34" charset="0"/>
+                <a:ea typeface="Arial" pitchFamily="34" charset="-122"/>
+                <a:cs typeface="Arial" pitchFamily="34" charset="-120"/>
+              </a:rPr>
+              <a:t>El Random Oracle Paradox</a:t>
+            </a:r>
+          </a:p>
+        </p:txBody>
+      </p:sp>
+      <p:sp>
+        <p:nvSpPr>
+          <p:cNvPr id="4" name="Text 2"/>
+          <p:cNvSpPr/>
+          <p:nvPr/>
+        </p:nvSpPr>
+        <p:spPr>
+          <a:xfrm>
+            <a:off x="365760" y="640080"/>
+            <a:ext cx="8412480" cy="274320"/>
+          </a:xfrm>
+          <a:prstGeom prst="rect">
+            <a:avLst/>
+          </a:prstGeom>
+          <a:noFill/>
+          <a:ln/>
+        </p:spPr>
+        <p:txBody>
+          <a:bodyPr wrap="square" lIns="0" tIns="0" rIns="0" bIns="0" rtlCol="0" anchor="ctr"/>
+          <a:lstStyle/>
+          <a:p>
+            <a:pPr indent="0" marL="0">
+              <a:buNone/>
+            </a:pPr>
+            <a:r>
+              <a:rPr lang="en-US" sz="1250" i="1" dirty="0">
+                <a:solidFill>
+                  <a:srgbClr val="BFDBFE"/>
+                </a:solidFill>
+              </a:rPr>
+              <a:t>Por qué no se puede tomar XMSS existente y meterlo en un SNARK directamente</a:t>
+            </a:r>
+          </a:p>
+        </p:txBody>
+      </p:sp>
+      <p:sp>
+        <p:nvSpPr>
+          <p:cNvPr id="5" name="Shape 3"/>
+          <p:cNvSpPr/>
+          <p:nvPr/>
+        </p:nvSpPr>
+        <p:spPr>
+          <a:xfrm>
+            <a:off x="365760" y="1097280"/>
+            <a:ext cx="4114800" cy="2743200"/>
+          </a:xfrm>
+          <a:prstGeom prst="rect">
+            <a:avLst/>
+          </a:prstGeom>
+          <a:solidFill>
+            <a:srgbClr val="0F1E3D"/>
+          </a:solidFill>
+          <a:ln w="19050">
+            <a:solidFill>
+              <a:srgbClr val="F5A623"/>
+            </a:solidFill>
+            <a:prstDash val="solid"/>
+          </a:ln>
+          <a:effectLst>
+            <a:outerShdw sx="100000" sy="100000" kx="0" ky="0" algn="bl" rotWithShape="0" blurRad="101600" dist="38100" dir="8100000">
+              <a:srgbClr val="000000">
+                <a:alpha val="30000"/>
+              </a:srgbClr>
+            </a:outerShdw>
+          </a:effectLst>
+        </p:spPr>
+      </p:sp>
+      <p:sp>
+        <p:nvSpPr>
+          <p:cNvPr id="6" name="Text 4"/>
+          <p:cNvSpPr/>
+          <p:nvPr/>
+        </p:nvSpPr>
+        <p:spPr>
+          <a:xfrm>
+            <a:off x="502920" y="1143000"/>
+            <a:ext cx="3886200" cy="2651760"/>
+          </a:xfrm>
+          <a:prstGeom prst="rect">
+            <a:avLst/>
+          </a:prstGeom>
+          <a:noFill/>
+          <a:ln/>
+        </p:spPr>
+        <p:txBody>
+          <a:bodyPr wrap="square" lIns="91440" tIns="45720" rIns="91440" bIns="45720" rtlCol="0" anchor="t"/>
+          <a:lstStyle/>
+          <a:p>
+            <a:pPr indent="0" marL="0">
+              <a:buNone/>
+            </a:pPr>
+            <a:r>
+              <a:rPr lang="en-US" sz="1200" b="1" dirty="0">
+                <a:solidFill>
+                  <a:srgbClr val="F5A623"/>
+                </a:solidFill>
+              </a:rPr>
+              <a:t>El problema</a:t>
+            </a:r>
+          </a:p>
+          <a:p>
+            <a:pPr indent="0" marL="0">
+              <a:buNone/>
+            </a:pPr>
+            <a:r>
+              <a:rPr lang="en-US" sz="400" dirty="0">
+                <a:solidFill>
+                  <a:srgbClr val="080E1A"/>
+                </a:solidFill>
+              </a:rPr>
+              <a:t xml:space="preserve"> </a:t>
+            </a:r>
+          </a:p>
+          <a:p>
+            <a:pPr indent="0" marL="0">
+              <a:buNone/>
+            </a:pPr>
+            <a:r>
+              <a:rPr lang="en-US" sz="950" dirty="0">
+                <a:solidFill>
+                  <a:srgbClr val="BFDBFE"/>
+                </a:solidFill>
+              </a:rPr>
+              <a:t>Para probar que XMSS es seguro, las pruebas matemáticas asumen que la función hash se comporta como un random oracle: una caja negra mágica que devuelve valores aleatorios.</a:t>
+            </a:r>
+          </a:p>
+          <a:p>
+            <a:pPr indent="0" marL="0">
+              <a:buNone/>
+            </a:pPr>
+            <a:r>
+              <a:rPr lang="en-US" sz="400" dirty="0">
+                <a:solidFill>
+                  <a:srgbClr val="080E1A"/>
+                </a:solidFill>
+              </a:rPr>
+              <a:t xml:space="preserve"> </a:t>
+            </a:r>
+          </a:p>
+          <a:p>
+            <a:pPr indent="0" marL="0">
+              <a:buNone/>
+            </a:pPr>
+            <a:r>
+              <a:rPr lang="en-US" sz="950" dirty="0">
+                <a:solidFill>
+                  <a:srgbClr val="BFDBFE"/>
+                </a:solidFill>
+              </a:rPr>
+              <a:t>Pero el SNARK necesita tratar la función hash como un circuito explícito y concreto.</a:t>
+            </a:r>
+          </a:p>
+          <a:p>
+            <a:pPr indent="0" marL="0">
+              <a:buNone/>
+            </a:pPr>
+            <a:r>
+              <a:rPr lang="en-US" sz="400" dirty="0">
+                <a:solidFill>
+                  <a:srgbClr val="080E1A"/>
+                </a:solidFill>
+              </a:rPr>
+              <a:t xml:space="preserve"> </a:t>
+            </a:r>
+          </a:p>
+          <a:p>
+            <a:pPr indent="0" marL="0">
+              <a:buNone/>
+            </a:pPr>
+            <a:r>
+              <a:rPr lang="en-US" sz="950" b="1" dirty="0">
+                <a:solidFill>
+                  <a:srgbClr val="F5A623"/>
+                </a:solidFill>
+              </a:rPr>
+              <a:t>Son dos cosas contradictorias:</a:t>
+            </a:r>
+          </a:p>
+          <a:p>
+            <a:pPr indent="0" marL="0">
+              <a:buNone/>
+            </a:pPr>
+            <a:r>
+              <a:rPr lang="en-US" sz="400" dirty="0">
+                <a:solidFill>
+                  <a:srgbClr val="080E1A"/>
+                </a:solidFill>
+              </a:rPr>
+              <a:t xml:space="preserve"> </a:t>
+            </a:r>
+          </a:p>
+          <a:p>
+            <a:pPr indent="0" marL="0">
+              <a:buNone/>
+            </a:pPr>
+            <a:r>
+              <a:rPr lang="en-US" sz="900" dirty="0">
+                <a:solidFill>
+                  <a:srgbClr val="BFDBFE"/>
+                </a:solidFill>
+                <a:latin typeface="Consolas"/>
+              </a:rPr>
+              <a:t>Prueba de seguridad XMSS:</a:t>
+            </a:r>
+          </a:p>
+          <a:p>
+            <a:pPr indent="0" marL="0">
+              <a:buNone/>
+            </a:pPr>
+            <a:r>
+              <a:rPr lang="en-US" sz="900" dirty="0">
+                <a:solidFill>
+                  <a:srgbClr val="BFDBFE"/>
+                </a:solidFill>
+                <a:latin typeface="Consolas"/>
+              </a:rPr>
+              <a:t xml:space="preserve">  "hash = caja negra mágica"</a:t>
+            </a:r>
+          </a:p>
+          <a:p>
+            <a:pPr algn="ctr" indent="0" marL="0">
+              <a:buNone/>
+            </a:pPr>
+            <a:r>
+              <a:rPr lang="en-US" sz="1000" b="1" dirty="0">
+                <a:solidFill>
+                  <a:srgbClr val="EF4444"/>
+                </a:solidFill>
+                <a:latin typeface="Consolas"/>
+              </a:rPr>
+              <a:t>↕ CONTRADICCIÓN</a:t>
+            </a:r>
+          </a:p>
+          <a:p>
+            <a:pPr indent="0" marL="0">
+              <a:buNone/>
+            </a:pPr>
+            <a:r>
+              <a:rPr lang="en-US" sz="900" dirty="0">
+                <a:solidFill>
+                  <a:srgbClr val="BFDBFE"/>
+                </a:solidFill>
+                <a:latin typeface="Consolas"/>
+              </a:rPr>
+              <a:t>El SNARK necesita:</a:t>
+            </a:r>
+          </a:p>
+          <a:p>
+            <a:pPr indent="0" marL="0">
+              <a:buNone/>
+            </a:pPr>
+            <a:r>
+              <a:rPr lang="en-US" sz="900" dirty="0">
+                <a:solidFill>
+                  <a:srgbClr val="BFDBFE"/>
+                </a:solidFill>
+                <a:latin typeface="Consolas"/>
+              </a:rPr>
+              <a:t xml:space="preserve">  "hash = circuito concreto"</a:t>
+            </a:r>
+          </a:p>
+        </p:txBody>
+      </p:sp>
+      <p:sp>
+        <p:nvSpPr>
+          <p:cNvPr id="7" name="Shape 5"/>
+          <p:cNvSpPr/>
+          <p:nvPr/>
+        </p:nvSpPr>
+        <p:spPr>
+          <a:xfrm>
+            <a:off x="4663440" y="1097280"/>
+            <a:ext cx="4114800" cy="2743200"/>
+          </a:xfrm>
+          <a:prstGeom prst="rect">
+            <a:avLst/>
+          </a:prstGeom>
+          <a:solidFill>
+            <a:srgbClr val="0F1E3D"/>
+          </a:solidFill>
+          <a:ln w="19050">
+            <a:solidFill>
+              <a:srgbClr val="4A90D9"/>
+            </a:solidFill>
+            <a:prstDash val="solid"/>
+          </a:ln>
+          <a:effectLst>
+            <a:outerShdw sx="100000" sy="100000" kx="0" ky="0" algn="bl" rotWithShape="0" blurRad="101600" dist="38100" dir="8100000">
+              <a:srgbClr val="000000">
+                <a:alpha val="30000"/>
+              </a:srgbClr>
+            </a:outerShdw>
+          </a:effectLst>
+        </p:spPr>
+      </p:sp>
+      <p:sp>
+        <p:nvSpPr>
+          <p:cNvPr id="8" name="Text 6"/>
+          <p:cNvSpPr/>
+          <p:nvPr/>
+        </p:nvSpPr>
+        <p:spPr>
+          <a:xfrm>
+            <a:off x="4800600" y="1143000"/>
+            <a:ext cx="3886200" cy="2651760"/>
+          </a:xfrm>
+          <a:prstGeom prst="rect">
+            <a:avLst/>
+          </a:prstGeom>
+          <a:noFill/>
+          <a:ln/>
+        </p:spPr>
+        <p:txBody>
+          <a:bodyPr wrap="square" lIns="91440" tIns="45720" rIns="91440" bIns="45720" rtlCol="0" anchor="t"/>
+          <a:lstStyle/>
+          <a:p>
+            <a:pPr indent="0" marL="0">
+              <a:buNone/>
+            </a:pPr>
+            <a:r>
+              <a:rPr lang="en-US" sz="1200" b="1" dirty="0">
+                <a:solidFill>
+                  <a:srgbClr val="4A90D9"/>
+                </a:solidFill>
+              </a:rPr>
+              <a:t>La solución del paper</a:t>
+            </a:r>
+          </a:p>
+          <a:p>
+            <a:pPr indent="0" marL="0">
+              <a:buNone/>
+            </a:pPr>
+            <a:r>
+              <a:rPr lang="en-US" sz="400" dirty="0">
+                <a:solidFill>
+                  <a:srgbClr val="080E1A"/>
+                </a:solidFill>
+              </a:rPr>
+              <a:t xml:space="preserve"> </a:t>
+            </a:r>
+          </a:p>
+          <a:p>
+            <a:pPr indent="0" marL="0">
+              <a:buNone/>
+            </a:pPr>
+            <a:r>
+              <a:rPr lang="en-US" sz="1000" dirty="0">
+                <a:solidFill>
+                  <a:srgbClr val="BFDBFE"/>
+                </a:solidFill>
+              </a:rPr>
+              <a:t>En vez de asumir random oracle, prueban la seguridad usando propiedades concretas de la función hash en el modelo estándar:</a:t>
+            </a:r>
+          </a:p>
+          <a:p>
+            <a:pPr indent="0" marL="0">
+              <a:buNone/>
+            </a:pPr>
+            <a:r>
+              <a:rPr lang="en-US" sz="400" dirty="0">
+                <a:solidFill>
+                  <a:srgbClr val="080E1A"/>
+                </a:solidFill>
+              </a:rPr>
+              <a:t xml:space="preserve"> </a:t>
+            </a:r>
+          </a:p>
+          <a:p>
+            <a:pPr indent="0" marL="0">
+              <a:buNone/>
+            </a:pPr>
+            <a:r>
+              <a:rPr lang="en-US" sz="1050" b="1" dirty="0">
+                <a:solidFill>
+                  <a:srgbClr val="4A90D9"/>
+                </a:solidFill>
+              </a:rPr>
+              <a:t>SM-TCR</a:t>
+            </a:r>
+            <a:r>
+              <a:rPr lang="en-US" sz="1050" dirty="0">
+                <a:solidFill>
+                  <a:srgbClr val="BFDBFE"/>
+                </a:solidFill>
+              </a:rPr>
+              <a:t xml:space="preserve">  resistencia a colisiones multi-target</a:t>
+            </a:r>
+          </a:p>
+          <a:p>
+            <a:pPr indent="0" marL="0">
+              <a:buNone/>
+            </a:pPr>
+            <a:r>
+              <a:rPr lang="en-US" sz="400" dirty="0">
+                <a:solidFill>
+                  <a:srgbClr val="080E1A"/>
+                </a:solidFill>
+              </a:rPr>
+              <a:t xml:space="preserve"> </a:t>
+            </a:r>
+          </a:p>
+          <a:p>
+            <a:pPr indent="0" marL="0">
+              <a:buNone/>
+            </a:pPr>
+            <a:r>
+              <a:rPr lang="en-US" sz="1050" b="1" dirty="0">
+                <a:solidFill>
+                  <a:srgbClr val="4A90D9"/>
+                </a:solidFill>
+              </a:rPr>
+              <a:t>SM-PRE</a:t>
+            </a:r>
+            <a:r>
+              <a:rPr lang="en-US" sz="1050" dirty="0">
+                <a:solidFill>
+                  <a:srgbClr val="BFDBFE"/>
+                </a:solidFill>
+              </a:rPr>
+              <a:t xml:space="preserve">  resistencia a preimagen multi-target</a:t>
+            </a:r>
+          </a:p>
+          <a:p>
+            <a:pPr indent="0" marL="0">
+              <a:buNone/>
+            </a:pPr>
+            <a:r>
+              <a:rPr lang="en-US" sz="400" dirty="0">
+                <a:solidFill>
+                  <a:srgbClr val="080E1A"/>
+                </a:solidFill>
+              </a:rPr>
+              <a:t xml:space="preserve"> </a:t>
+            </a:r>
+          </a:p>
+          <a:p>
+            <a:pPr indent="0" marL="0">
+              <a:buNone/>
+            </a:pPr>
+            <a:r>
+              <a:rPr lang="en-US" sz="1050" b="1" dirty="0">
+                <a:solidFill>
+                  <a:srgbClr val="4A90D9"/>
+                </a:solidFill>
+              </a:rPr>
+              <a:t>SM-UD</a:t>
+            </a:r>
+            <a:r>
+              <a:rPr lang="en-US" sz="1050" dirty="0">
+                <a:solidFill>
+                  <a:srgbClr val="BFDBFE"/>
+                </a:solidFill>
+              </a:rPr>
+              <a:t xml:space="preserve">  indetectabilidad multi-target</a:t>
+            </a:r>
+          </a:p>
+          <a:p>
+            <a:pPr indent="0" marL="0">
+              <a:buNone/>
+            </a:pPr>
+            <a:r>
+              <a:rPr lang="en-US" sz="400" dirty="0">
+                <a:solidFill>
+                  <a:srgbClr val="080E1A"/>
+                </a:solidFill>
+              </a:rPr>
+              <a:t xml:space="preserve"> </a:t>
+            </a:r>
+          </a:p>
+          <a:p>
+            <a:pPr indent="0" marL="0">
+              <a:buNone/>
+            </a:pPr>
+            <a:r>
+              <a:rPr lang="en-US" sz="1000" dirty="0">
+                <a:solidFill>
+                  <a:srgbClr val="BFDBFE"/>
+                </a:solidFill>
+              </a:rPr>
+              <a:t>Así la función hash puede ser un circuito concreto sin contradicción. Este es uno de los aportes más importantes del paper.</a:t>
+            </a:r>
+          </a:p>
+        </p:txBody>
+      </p:sp>
+      <p:sp>
+        <p:nvSpPr>
+          <p:cNvPr id="9" name="Shape 7"/>
+          <p:cNvSpPr/>
+          <p:nvPr/>
+        </p:nvSpPr>
+        <p:spPr>
+          <a:xfrm>
+            <a:off x="365760" y="4023360"/>
+            <a:ext cx="8412480" cy="548640"/>
+          </a:xfrm>
+          <a:prstGeom prst="rect">
+            <a:avLst/>
+          </a:prstGeom>
+          <a:solidFill>
+            <a:srgbClr val="4A90D9">
+              <a:alpha val="15000"/>
+            </a:srgbClr>
+          </a:solidFill>
+          <a:ln w="19050">
+            <a:solidFill>
+              <a:srgbClr val="4A90D9"/>
+            </a:solidFill>
+            <a:prstDash val="solid"/>
+          </a:ln>
+        </p:spPr>
+      </p:sp>
+      <p:sp>
+        <p:nvSpPr>
+          <p:cNvPr id="10" name="Text 8"/>
+          <p:cNvSpPr/>
+          <p:nvPr/>
+        </p:nvSpPr>
+        <p:spPr>
+          <a:xfrm>
+            <a:off x="502920" y="4023360"/>
+            <a:ext cx="8138160" cy="548640"/>
+          </a:xfrm>
+          <a:prstGeom prst="rect">
+            <a:avLst/>
+          </a:prstGeom>
+          <a:noFill/>
+          <a:ln/>
+        </p:spPr>
+        <p:txBody>
+          <a:bodyPr wrap="square" lIns="91440" tIns="45720" rIns="91440" bIns="45720" rtlCol="0" anchor="ctr"/>
+          <a:lstStyle/>
+          <a:p>
+            <a:pPr indent="0" marL="0">
+              <a:buNone/>
+            </a:pPr>
+            <a:r>
+              <a:rPr lang="en-US" sz="950" dirty="0">
+                <a:solidFill>
+                  <a:srgbClr val="4A90D9"/>
+                </a:solidFill>
+              </a:rPr>
+              <a:t>Fuente: "Hash-Based Multi-Signatures for Post-Quantum Ethereum" — Drake, Khovratovich, Kudinov, Wagner (Ethereum Foundation / TU Eindhoven, 2025)</a:t>
+            </a:r>
+          </a:p>
+        </p:txBody>
+      </p:sp>
+    </p:spTree>
+  </p:cSld>
+  <p:clrMapOvr>
+    <a:masterClrMapping/>
+  </p:clrMapOvr>
+</p:sld>
+</file>
+
+<file path=ppt/slides/slide23.xml><?xml version="1.0" encoding="utf-8"?>
+<p:sld xmlns:a="http://schemas.openxmlformats.org/drawingml/2006/main" xmlns:r="http://schemas.openxmlformats.org/officeDocument/2006/relationships" xmlns:p="http://schemas.openxmlformats.org/presentationml/2006/main">
+  <p:cSld name="Slide 23">
+    <p:bg>
+      <p:bgPr>
+        <a:solidFill>
+          <a:srgbClr val="080E1A"/>
+        </a:solidFill>
+      </p:bgPr>
+    </p:bg>
+    <p:spTree>
+      <p:nvGrpSpPr>
+        <p:cNvPr id="1" name=""/>
+        <p:cNvGrpSpPr/>
+        <p:nvPr/>
+      </p:nvGrpSpPr>
+      <p:grpSpPr>
+        <a:xfrm>
+          <a:off x="0" y="0"/>
+          <a:ext cx="0" cy="0"/>
+          <a:chOff x="0" y="0"/>
+          <a:chExt cx="0" cy="0"/>
+        </a:xfrm>
+      </p:grpSpPr>
+      <p:sp>
+        <p:nvSpPr>
+          <p:cNvPr id="2" name="Shape 0"/>
+          <p:cNvSpPr/>
+          <p:nvPr/>
+        </p:nvSpPr>
+        <p:spPr>
+          <a:xfrm>
+            <a:off x="0" y="0"/>
+            <a:ext cx="9144000" cy="960120"/>
+          </a:xfrm>
+          <a:prstGeom prst="rect">
+            <a:avLst/>
+          </a:prstGeom>
+          <a:solidFill>
+            <a:srgbClr val="B45309"/>
+          </a:solidFill>
+          <a:ln w="12700">
+            <a:solidFill>
+              <a:srgbClr val="333333"/>
+            </a:solidFill>
+            <a:prstDash val="solid"/>
+          </a:ln>
+        </p:spPr>
+      </p:sp>
+      <p:sp>
+        <p:nvSpPr>
+          <p:cNvPr id="3" name="Text 1"/>
+          <p:cNvSpPr/>
+          <p:nvPr/>
+        </p:nvSpPr>
+        <p:spPr>
+          <a:xfrm>
+            <a:off x="365760" y="182880"/>
+            <a:ext cx="8412480" cy="457200"/>
+          </a:xfrm>
+          <a:prstGeom prst="rect">
+            <a:avLst/>
+          </a:prstGeom>
+          <a:noFill/>
+          <a:ln/>
+        </p:spPr>
+        <p:txBody>
+          <a:bodyPr wrap="square" lIns="0" tIns="0" rIns="0" bIns="0" rtlCol="0" anchor="ctr"/>
+          <a:lstStyle/>
+          <a:p>
+            <a:pPr indent="0" marL="0">
+              <a:buNone/>
+            </a:pPr>
+            <a:r>
+              <a:rPr lang="en-US" sz="2600" b="1" dirty="0">
+                <a:solidFill>
+                  <a:srgbClr val="F8FAFC"/>
+                </a:solidFill>
+                <a:latin typeface="Arial" pitchFamily="34" charset="0"/>
+                <a:ea typeface="Arial" pitchFamily="34" charset="-122"/>
+                <a:cs typeface="Arial" pitchFamily="34" charset="-120"/>
+              </a:rPr>
+              <a:t>Target Sum Winternitz (TSW)</a:t>
+            </a:r>
+          </a:p>
+        </p:txBody>
+      </p:sp>
+      <p:sp>
+        <p:nvSpPr>
+          <p:cNvPr id="4" name="Text 2"/>
+          <p:cNvSpPr/>
+          <p:nvPr/>
+        </p:nvSpPr>
+        <p:spPr>
+          <a:xfrm>
+            <a:off x="365760" y="640080"/>
+            <a:ext cx="8412480" cy="274320"/>
+          </a:xfrm>
+          <a:prstGeom prst="rect">
+            <a:avLst/>
+          </a:prstGeom>
+          <a:noFill/>
+          <a:ln/>
+        </p:spPr>
+        <p:txBody>
+          <a:bodyPr wrap="square" lIns="0" tIns="0" rIns="0" bIns="0" rtlCol="0" anchor="ctr"/>
+          <a:lstStyle/>
+          <a:p>
+            <a:pPr indent="0" marL="0">
+              <a:buNone/>
+            </a:pPr>
+            <a:r>
+              <a:rPr lang="en-US" sz="1250" i="1" dirty="0">
+                <a:solidFill>
+                  <a:srgbClr val="BFDBFE"/>
+                </a:solidFill>
+              </a:rPr>
+              <a:t>La variante nueva que hace eficiente la agregación con SNARKs</a:t>
+            </a:r>
+          </a:p>
+        </p:txBody>
+      </p:sp>
+      <p:sp>
+        <p:nvSpPr>
+          <p:cNvPr id="5" name="Shape 3"/>
+          <p:cNvSpPr/>
+          <p:nvPr/>
+        </p:nvSpPr>
+        <p:spPr>
+          <a:xfrm>
+            <a:off x="365760" y="1097280"/>
+            <a:ext cx="4114800" cy="1371600"/>
+          </a:xfrm>
+          <a:prstGeom prst="rect">
+            <a:avLst/>
+          </a:prstGeom>
+          <a:solidFill>
+            <a:srgbClr val="0F1E3D"/>
+          </a:solidFill>
+          <a:ln w="19050">
+            <a:solidFill>
+              <a:srgbClr val="F5A623"/>
+            </a:solidFill>
+            <a:prstDash val="solid"/>
+          </a:ln>
+          <a:effectLst>
+            <a:outerShdw sx="100000" sy="100000" kx="0" ky="0" algn="bl" rotWithShape="0" blurRad="101600" dist="38100" dir="8100000">
+              <a:srgbClr val="000000">
+                <a:alpha val="30000"/>
+              </a:srgbClr>
+            </a:outerShdw>
+          </a:effectLst>
+        </p:spPr>
+      </p:sp>
+      <p:sp>
+        <p:nvSpPr>
+          <p:cNvPr id="6" name="Text 4"/>
+          <p:cNvSpPr/>
+          <p:nvPr/>
+        </p:nvSpPr>
+        <p:spPr>
+          <a:xfrm>
+            <a:off x="502920" y="1143000"/>
+            <a:ext cx="3886200" cy="1280160"/>
+          </a:xfrm>
+          <a:prstGeom prst="rect">
+            <a:avLst/>
+          </a:prstGeom>
+          <a:noFill/>
+          <a:ln/>
+        </p:spPr>
+        <p:txBody>
+          <a:bodyPr wrap="square" lIns="91440" tIns="45720" rIns="91440" bIns="45720" rtlCol="0" anchor="t"/>
+          <a:lstStyle/>
+          <a:p>
+            <a:pPr indent="0" marL="0">
+              <a:buNone/>
+            </a:pPr>
+            <a:r>
+              <a:rPr lang="en-US" sz="1200" b="1" dirty="0">
+                <a:solidFill>
+                  <a:srgbClr val="F5A623"/>
+                </a:solidFill>
+              </a:rPr>
+              <a:t>Winternitz clásico (problema)</a:t>
+            </a:r>
+          </a:p>
+          <a:p>
+            <a:pPr indent="0" marL="0">
+              <a:buNone/>
+            </a:pPr>
+            <a:r>
+              <a:rPr lang="en-US" sz="400" dirty="0">
+                <a:solidFill>
+                  <a:srgbClr val="080E1A"/>
+                </a:solidFill>
+              </a:rPr>
+              <a:t xml:space="preserve"> </a:t>
+            </a:r>
+          </a:p>
+          <a:p>
+            <a:pPr indent="0" marL="0">
+              <a:buNone/>
+            </a:pPr>
+            <a:r>
+              <a:rPr lang="en-US" sz="1050" dirty="0">
+                <a:solidFill>
+                  <a:srgbClr val="BFDBFE"/>
+                </a:solidFill>
+              </a:rPr>
+              <a:t>El número de hashes al verificar depende del mensaje:</a:t>
+            </a:r>
+          </a:p>
+          <a:p>
+            <a:pPr indent="0" marL="0">
+              <a:buNone/>
+            </a:pPr>
+            <a:r>
+              <a:rPr lang="en-US" sz="1050" dirty="0">
+                <a:solidFill>
+                  <a:srgbClr val="BFDBFE"/>
+                </a:solidFill>
+              </a:rPr>
+              <a:t xml:space="preserve">  • Varía en cada verificación</a:t>
+            </a:r>
+          </a:p>
+          <a:p>
+            <a:pPr indent="0" marL="0">
+              <a:buNone/>
+            </a:pPr>
+            <a:r>
+              <a:rPr lang="en-US" sz="1050" dirty="0">
+                <a:solidFill>
+                  <a:srgbClr val="BFDBFE"/>
+                </a:solidFill>
+              </a:rPr>
+              <a:t xml:space="preserve">  • Circuito SNARK de tamaño variable → muy costoso</a:t>
+            </a:r>
+          </a:p>
+        </p:txBody>
+      </p:sp>
+      <p:sp>
+        <p:nvSpPr>
+          <p:cNvPr id="7" name="Shape 5"/>
+          <p:cNvSpPr/>
+          <p:nvPr/>
+        </p:nvSpPr>
+        <p:spPr>
+          <a:xfrm>
+            <a:off x="4663440" y="1097280"/>
+            <a:ext cx="4114800" cy="1371600"/>
+          </a:xfrm>
+          <a:prstGeom prst="rect">
+            <a:avLst/>
+          </a:prstGeom>
+          <a:solidFill>
+            <a:srgbClr val="0F1E3D"/>
+          </a:solidFill>
+          <a:ln w="19050">
+            <a:solidFill>
+              <a:srgbClr val="10B981"/>
+            </a:solidFill>
+            <a:prstDash val="solid"/>
+          </a:ln>
+          <a:effectLst>
+            <a:outerShdw sx="100000" sy="100000" kx="0" ky="0" algn="bl" rotWithShape="0" blurRad="101600" dist="38100" dir="8100000">
+              <a:srgbClr val="000000">
+                <a:alpha val="30000"/>
+              </a:srgbClr>
+            </a:outerShdw>
+          </a:effectLst>
+        </p:spPr>
+      </p:sp>
+      <p:sp>
+        <p:nvSpPr>
+          <p:cNvPr id="8" name="Text 6"/>
+          <p:cNvSpPr/>
+          <p:nvPr/>
+        </p:nvSpPr>
+        <p:spPr>
+          <a:xfrm>
+            <a:off x="4800600" y="1143000"/>
+            <a:ext cx="3886200" cy="1280160"/>
+          </a:xfrm>
+          <a:prstGeom prst="rect">
+            <a:avLst/>
+          </a:prstGeom>
+          <a:noFill/>
+          <a:ln/>
+        </p:spPr>
+        <p:txBody>
+          <a:bodyPr wrap="square" lIns="91440" tIns="45720" rIns="91440" bIns="45720" rtlCol="0" anchor="t"/>
+          <a:lstStyle/>
+          <a:p>
+            <a:pPr indent="0" marL="0">
+              <a:buNone/>
+            </a:pPr>
+            <a:r>
+              <a:rPr lang="en-US" sz="1200" b="1" dirty="0">
+                <a:solidFill>
+                  <a:srgbClr val="10B981"/>
+                </a:solidFill>
+              </a:rPr>
+              <a:t>La solución TSW</a:t>
+            </a:r>
+          </a:p>
+          <a:p>
+            <a:pPr indent="0" marL="0">
+              <a:buNone/>
+            </a:pPr>
+            <a:r>
+              <a:rPr lang="en-US" sz="400" dirty="0">
+                <a:solidFill>
+                  <a:srgbClr val="080E1A"/>
+                </a:solidFill>
+              </a:rPr>
+              <a:t xml:space="preserve"> </a:t>
+            </a:r>
+          </a:p>
+          <a:p>
+            <a:pPr indent="0" marL="0">
+              <a:buNone/>
+            </a:pPr>
+            <a:r>
+              <a:rPr lang="en-US" sz="1050" dirty="0">
+                <a:solidFill>
+                  <a:srgbClr val="BFDBFE"/>
+                </a:solidFill>
+              </a:rPr>
+              <a:t>Exige que la suma de todos los dígitos del encoding sea exactamente T (un target fijo).</a:t>
+            </a:r>
+          </a:p>
+          <a:p>
+            <a:pPr indent="0" marL="0">
+              <a:buNone/>
+            </a:pPr>
+            <a:r>
+              <a:rPr lang="en-US" sz="400" dirty="0">
+                <a:solidFill>
+                  <a:srgbClr val="080E1A"/>
+                </a:solidFill>
+              </a:rPr>
+              <a:t xml:space="preserve"> </a:t>
+            </a:r>
+          </a:p>
+          <a:p>
+            <a:pPr indent="0" marL="0">
+              <a:buNone/>
+            </a:pPr>
+            <a:r>
+              <a:rPr lang="en-US" sz="1050" dirty="0">
+                <a:solidFill>
+                  <a:srgbClr val="BFDBFE"/>
+                </a:solidFill>
+              </a:rPr>
+              <a:t>Si el hash no suma T → se rehashea con nueva aleatoriedad hasta lograrlo.</a:t>
+            </a:r>
+          </a:p>
+        </p:txBody>
+      </p:sp>
+      <p:sp>
+        <p:nvSpPr>
+          <p:cNvPr id="30" name="Shape 30"/>
+          <p:cNvSpPr/>
+          <p:nvPr/>
+        </p:nvSpPr>
+        <p:spPr>
+          <a:xfrm>
+            <a:off x="365760" y="2651760"/>
+            <a:ext cx="2651760" cy="594360"/>
+          </a:xfrm>
+          <a:prstGeom prst="rect">
+            <a:avLst/>
+          </a:prstGeom>
+          <a:solidFill>
+            <a:srgbClr val="0F1E3D"/>
+          </a:solidFill>
+          <a:ln w="19050">
+            <a:solidFill>
+              <a:srgbClr val="10B981"/>
+            </a:solidFill>
+            <a:prstDash val="solid"/>
+          </a:ln>
+        </p:spPr>
+      </p:sp>
+      <p:sp>
+        <p:nvSpPr>
+          <p:cNvPr id="31" name="Text 31"/>
+          <p:cNvSpPr/>
+          <p:nvPr/>
+        </p:nvSpPr>
+        <p:spPr>
+          <a:xfrm>
+            <a:off x="365760" y="2651760"/>
+            <a:ext cx="2651760" cy="594360"/>
+          </a:xfrm>
+          <a:prstGeom prst="rect">
+            <a:avLst/>
+          </a:prstGeom>
+          <a:noFill/>
+          <a:ln/>
+        </p:spPr>
+        <p:txBody>
+          <a:bodyPr wrap="square" lIns="91440" tIns="45720" rIns="91440" bIns="45720" rtlCol="0" anchor="ctr"/>
+          <a:lstStyle/>
+          <a:p>
+            <a:pPr indent="0" marL="0">
+              <a:buNone/>
+            </a:pPr>
+            <a:r>
+              <a:rPr lang="en-US" sz="1000" b="1" dirty="0">
+                <a:solidFill>
+                  <a:srgbClr val="10B981"/>
+                </a:solidFill>
+              </a:rPr>
+              <a:t>✅ Sin checksum</a:t>
+            </a:r>
+          </a:p>
+          <a:p>
+            <a:pPr indent="0" marL="0">
+              <a:buNone/>
+            </a:pPr>
+            <a:r>
+              <a:rPr lang="en-US" sz="900" dirty="0">
+                <a:solidFill>
+                  <a:srgbClr val="BFDBFE"/>
+                </a:solidFill>
+              </a:rPr>
+              <a:t>Firma más pequeña</a:t>
+            </a:r>
+          </a:p>
+        </p:txBody>
+      </p:sp>
+      <p:sp>
+        <p:nvSpPr>
+          <p:cNvPr id="32" name="Shape 32"/>
+          <p:cNvSpPr/>
+          <p:nvPr/>
+        </p:nvSpPr>
+        <p:spPr>
+          <a:xfrm>
+            <a:off x="3200400" y="2651760"/>
+            <a:ext cx="2651760" cy="594360"/>
+          </a:xfrm>
+          <a:prstGeom prst="rect">
+            <a:avLst/>
+          </a:prstGeom>
+          <a:solidFill>
+            <a:srgbClr val="0F1E3D"/>
+          </a:solidFill>
+          <a:ln w="19050">
+            <a:solidFill>
+              <a:srgbClr val="10B981"/>
+            </a:solidFill>
+            <a:prstDash val="solid"/>
+          </a:ln>
+        </p:spPr>
+      </p:sp>
+      <p:sp>
+        <p:nvSpPr>
+          <p:cNvPr id="33" name="Text 33"/>
+          <p:cNvSpPr/>
+          <p:nvPr/>
+        </p:nvSpPr>
+        <p:spPr>
+          <a:xfrm>
+            <a:off x="3200400" y="2651760"/>
+            <a:ext cx="2651760" cy="594360"/>
+          </a:xfrm>
+          <a:prstGeom prst="rect">
+            <a:avLst/>
+          </a:prstGeom>
+          <a:noFill/>
+          <a:ln/>
+        </p:spPr>
+        <p:txBody>
+          <a:bodyPr wrap="square" lIns="91440" tIns="45720" rIns="91440" bIns="45720" rtlCol="0" anchor="ctr"/>
+          <a:lstStyle/>
+          <a:p>
+            <a:pPr indent="0" marL="0">
+              <a:buNone/>
+            </a:pPr>
+            <a:r>
+              <a:rPr lang="en-US" sz="1000" b="1" dirty="0">
+                <a:solidFill>
+                  <a:srgbClr val="10B981"/>
+                </a:solidFill>
+              </a:rPr>
+              <a:t>✅ Verificación determinística</a:t>
+            </a:r>
+          </a:p>
+          <a:p>
+            <a:pPr indent="0" marL="0">
+              <a:buNone/>
+            </a:pPr>
+            <a:r>
+              <a:rPr lang="en-US" sz="900" dirty="0">
+                <a:solidFill>
+                  <a:srgbClr val="BFDBFE"/>
+                </a:solidFill>
+              </a:rPr>
+              <a:t>Siempre misma cantidad de hashes</a:t>
+            </a:r>
+          </a:p>
+        </p:txBody>
+      </p:sp>
+      <p:sp>
+        <p:nvSpPr>
+          <p:cNvPr id="34" name="Shape 34"/>
+          <p:cNvSpPr/>
+          <p:nvPr/>
+        </p:nvSpPr>
+        <p:spPr>
+          <a:xfrm>
+            <a:off x="6035040" y="2651760"/>
+            <a:ext cx="2743200" cy="594360"/>
+          </a:xfrm>
+          <a:prstGeom prst="rect">
+            <a:avLst/>
+          </a:prstGeom>
+          <a:solidFill>
+            <a:srgbClr val="0F1E3D"/>
+          </a:solidFill>
+          <a:ln w="19050">
+            <a:solidFill>
+              <a:srgbClr val="10B981"/>
+            </a:solidFill>
+            <a:prstDash val="solid"/>
+          </a:ln>
+        </p:spPr>
+      </p:sp>
+      <p:sp>
+        <p:nvSpPr>
+          <p:cNvPr id="35" name="Text 35"/>
+          <p:cNvSpPr/>
+          <p:nvPr/>
+        </p:nvSpPr>
+        <p:spPr>
+          <a:xfrm>
+            <a:off x="6035040" y="2651760"/>
+            <a:ext cx="2743200" cy="594360"/>
+          </a:xfrm>
+          <a:prstGeom prst="rect">
+            <a:avLst/>
+          </a:prstGeom>
+          <a:noFill/>
+          <a:ln/>
+        </p:spPr>
+        <p:txBody>
+          <a:bodyPr wrap="square" lIns="91440" tIns="45720" rIns="91440" bIns="45720" rtlCol="0" anchor="ctr"/>
+          <a:lstStyle/>
+          <a:p>
+            <a:pPr indent="0" marL="0">
+              <a:buNone/>
+            </a:pPr>
+            <a:r>
+              <a:rPr lang="en-US" sz="1000" b="1" dirty="0">
+                <a:solidFill>
+                  <a:srgbClr val="10B981"/>
+                </a:solidFill>
+              </a:rPr>
+              <a:t>✅ Circuito SNARK fijo</a:t>
+            </a:r>
+          </a:p>
+          <a:p>
+            <a:pPr indent="0" marL="0">
+              <a:buNone/>
+            </a:pPr>
+            <a:r>
+              <a:rPr lang="en-US" sz="900" dirty="0">
+                <a:solidFill>
+                  <a:srgbClr val="BFDBFE"/>
+                </a:solidFill>
+              </a:rPr>
+              <a:t>Eficiencia predecible</a:t>
+            </a:r>
+          </a:p>
+        </p:txBody>
+      </p:sp>
+      <p:sp>
+        <p:nvSpPr>
+          <p:cNvPr id="40" name="Shape 40"/>
+          <p:cNvSpPr/>
+          <p:nvPr/>
+        </p:nvSpPr>
+        <p:spPr>
+          <a:xfrm>
+            <a:off x="365760" y="3428996"/>
+            <a:ext cx="8412480" cy="411480"/>
+          </a:xfrm>
+          <a:prstGeom prst="rect">
+            <a:avLst/>
+          </a:prstGeom>
+          <a:solidFill>
+            <a:srgbClr val="0F1E3D"/>
+          </a:solidFill>
+          <a:ln w="19050">
+            <a:solidFill>
+              <a:srgbClr val="3B82F6"/>
+            </a:solidFill>
+            <a:prstDash val="solid"/>
+          </a:ln>
+        </p:spPr>
+      </p:sp>
+      <p:sp>
+        <p:nvSpPr>
+          <p:cNvPr id="41" name="Text 41"/>
+          <p:cNvSpPr/>
+          <p:nvPr/>
+        </p:nvSpPr>
+        <p:spPr>
+          <a:xfrm>
+            <a:off x="502920" y="3428996"/>
+            <a:ext cx="8138160" cy="411480"/>
+          </a:xfrm>
+          <a:prstGeom prst="rect">
+            <a:avLst/>
+          </a:prstGeom>
+          <a:noFill/>
+          <a:ln/>
+        </p:spPr>
+        <p:txBody>
+          <a:bodyPr wrap="square" lIns="91440" tIns="27432" rIns="91440" bIns="27432" rtlCol="0" anchor="ctr"/>
+          <a:lstStyle/>
+          <a:p>
+            <a:pPr indent="0" marL="0">
+              <a:buNone/>
+            </a:pPr>
+            <a:r>
+              <a:rPr lang="en-US" sz="900" dirty="0">
+                <a:solidFill>
+                  <a:srgbClr val="BFDBFE"/>
+                </a:solidFill>
+                <a:latin typeface="Consolas"/>
+              </a:rPr>
+              <a:t>T grande → menos hashes en verificación → más reintentos al firmar</a:t>
+            </a:r>
+          </a:p>
+          <a:p>
+            <a:pPr indent="0" marL="0">
+              <a:buNone/>
+            </a:pPr>
+            <a:r>
+              <a:rPr lang="en-US" sz="900" dirty="0">
+                <a:solidFill>
+                  <a:srgbClr val="BFDBFE"/>
+                </a:solidFill>
+                <a:latin typeface="Consolas"/>
+              </a:rPr>
+              <a:t>T chico  → más hashes en verificación  → menos reintentos al firmar</a:t>
+            </a:r>
+          </a:p>
+        </p:txBody>
+      </p:sp>
+      <p:sp>
+        <p:nvSpPr>
+          <p:cNvPr id="11" name="Shape 9"/>
+          <p:cNvSpPr/>
+          <p:nvPr/>
+        </p:nvSpPr>
+        <p:spPr>
+          <a:xfrm>
+            <a:off x="365760" y="4023360"/>
+            <a:ext cx="8412480" cy="548640"/>
+          </a:xfrm>
+          <a:prstGeom prst="rect">
+            <a:avLst/>
+          </a:prstGeom>
+          <a:solidFill>
+            <a:srgbClr val="F5A623">
+              <a:alpha val="15000"/>
+            </a:srgbClr>
+          </a:solidFill>
+          <a:ln w="19050">
+            <a:solidFill>
+              <a:srgbClr val="F5A623"/>
+            </a:solidFill>
+            <a:prstDash val="solid"/>
+          </a:ln>
+        </p:spPr>
+      </p:sp>
+      <p:sp>
+        <p:nvSpPr>
+          <p:cNvPr id="12" name="Text 10"/>
+          <p:cNvSpPr/>
+          <p:nvPr/>
+        </p:nvSpPr>
+        <p:spPr>
+          <a:xfrm>
+            <a:off x="502920" y="4023360"/>
+            <a:ext cx="8138160" cy="548640"/>
+          </a:xfrm>
+          <a:prstGeom prst="rect">
+            <a:avLst/>
+          </a:prstGeom>
+          <a:noFill/>
+          <a:ln/>
+        </p:spPr>
+        <p:txBody>
+          <a:bodyPr wrap="square" lIns="91440" tIns="45720" rIns="91440" bIns="45720" rtlCol="0" anchor="ctr"/>
+          <a:lstStyle/>
+          <a:p>
+            <a:pPr indent="0" marL="0">
+              <a:buNone/>
+            </a:pPr>
+            <a:r>
+              <a:rPr lang="en-US" sz="1000" dirty="0">
+                <a:solidFill>
+                  <a:srgbClr val="F5A623"/>
+                </a:solidFill>
+              </a:rPr>
+              <a:t>⚠  TSW es una de las novedades principales del paper. Elimina el checksum y le da al circuito SNARK un tamaño fijo y predecible, clave para la eficiencia en producción.</a:t>
+            </a:r>
+          </a:p>
+        </p:txBody>
+      </p:sp>
+    </p:spTree>
+  </p:cSld>
+  <p:clrMapOvr>
+    <a:masterClrMapping/>
+  </p:clrMapOvr>
+</p:sld>
+</file>
+
+<file path=ppt/slides/slide24.xml><?xml version="1.0" encoding="utf-8"?>
+<p:sld xmlns:a="http://schemas.openxmlformats.org/drawingml/2006/main" xmlns:r="http://schemas.openxmlformats.org/officeDocument/2006/relationships" xmlns:p="http://schemas.openxmlformats.org/presentationml/2006/main">
+  <p:cSld name="Slide 24">
+    <p:bg>
+      <p:bgPr>
+        <a:solidFill>
+          <a:srgbClr val="080E1A"/>
+        </a:solidFill>
+      </p:bgPr>
+    </p:bg>
+    <p:spTree>
+      <p:nvGrpSpPr>
+        <p:cNvPr id="1" name=""/>
+        <p:cNvGrpSpPr/>
+        <p:nvPr/>
+      </p:nvGrpSpPr>
+      <p:grpSpPr>
+        <a:xfrm>
+          <a:off x="0" y="0"/>
+          <a:ext cx="0" cy="0"/>
+          <a:chOff x="0" y="0"/>
+          <a:chExt cx="0" cy="0"/>
+        </a:xfrm>
+      </p:grpSpPr>
+      <p:sp>
+        <p:nvSpPr>
+          <p:cNvPr id="2" name="Shape 0"/>
+          <p:cNvSpPr/>
+          <p:nvPr/>
+        </p:nvSpPr>
+        <p:spPr>
+          <a:xfrm>
+            <a:off x="0" y="0"/>
+            <a:ext cx="9144000" cy="960120"/>
+          </a:xfrm>
+          <a:prstGeom prst="rect">
+            <a:avLst/>
+          </a:prstGeom>
+          <a:solidFill>
+            <a:srgbClr val="065F46"/>
+          </a:solidFill>
+          <a:ln w="12700">
+            <a:solidFill>
+              <a:srgbClr val="333333"/>
+            </a:solidFill>
+            <a:prstDash val="solid"/>
+          </a:ln>
+        </p:spPr>
+      </p:sp>
+      <p:sp>
+        <p:nvSpPr>
+          <p:cNvPr id="3" name="Text 1"/>
+          <p:cNvSpPr/>
+          <p:nvPr/>
+        </p:nvSpPr>
+        <p:spPr>
+          <a:xfrm>
+            <a:off x="365760" y="182880"/>
+            <a:ext cx="8412480" cy="457200"/>
+          </a:xfrm>
+          <a:prstGeom prst="rect">
+            <a:avLst/>
+          </a:prstGeom>
+          <a:noFill/>
+          <a:ln/>
+        </p:spPr>
+        <p:txBody>
+          <a:bodyPr wrap="square" lIns="0" tIns="0" rIns="0" bIns="0" rtlCol="0" anchor="ctr"/>
+          <a:lstStyle/>
+          <a:p>
+            <a:pPr indent="0" marL="0">
+              <a:buNone/>
+            </a:pPr>
+            <a:r>
+              <a:rPr lang="en-US" sz="2600" b="1" dirty="0">
+                <a:solidFill>
+                  <a:srgbClr val="F8FAFC"/>
+                </a:solidFill>
+                <a:latin typeface="Arial" pitchFamily="34" charset="0"/>
+                <a:ea typeface="Arial" pitchFamily="34" charset="-122"/>
+                <a:cs typeface="Arial" pitchFamily="34" charset="-120"/>
+              </a:rPr>
+              <a:t>Resultados concretos del paper</a:t>
+            </a:r>
+          </a:p>
+        </p:txBody>
+      </p:sp>
+      <p:sp>
+        <p:nvSpPr>
+          <p:cNvPr id="4" name="Text 2"/>
+          <p:cNvSpPr/>
+          <p:nvPr/>
+        </p:nvSpPr>
+        <p:spPr>
+          <a:xfrm>
+            <a:off x="365760" y="640080"/>
+            <a:ext cx="8412480" cy="274320"/>
+          </a:xfrm>
+          <a:prstGeom prst="rect">
+            <a:avLst/>
+          </a:prstGeom>
+          <a:noFill/>
+          <a:ln/>
+        </p:spPr>
+        <p:txBody>
+          <a:bodyPr wrap="square" lIns="0" tIns="0" rIns="0" bIns="0" rtlCol="0" anchor="ctr"/>
+          <a:lstStyle/>
+          <a:p>
+            <a:pPr indent="0" marL="0">
+              <a:buNone/>
+            </a:pPr>
+            <a:r>
+              <a:rPr lang="en-US" sz="1250" i="1" dirty="0">
+                <a:solidFill>
+                  <a:srgbClr val="BFDBFE"/>
+                </a:solidFill>
+              </a:rPr>
+              <a:t>Parámetros: seguridad NIST Level 1 — 128 bits clásicos, 64 bits cuánticos</a:t>
+            </a:r>
+          </a:p>
+        </p:txBody>
+      </p:sp>
+      <p:sp>
+        <p:nvSpPr>
+          <p:cNvPr id="5" name="Shape 3"/>
+          <p:cNvSpPr/>
+          <p:nvPr/>
+        </p:nvSpPr>
+        <p:spPr>
+          <a:xfrm>
+            <a:off x="365760" y="1097280"/>
+            <a:ext cx="4114800" cy="1554480"/>
+          </a:xfrm>
+          <a:prstGeom prst="rect">
+            <a:avLst/>
+          </a:prstGeom>
+          <a:solidFill>
+            <a:srgbClr val="0F1E3D"/>
+          </a:solidFill>
+          <a:ln w="19050">
+            <a:solidFill>
+              <a:srgbClr val="F5A623"/>
+            </a:solidFill>
+            <a:prstDash val="solid"/>
+          </a:ln>
+          <a:effectLst>
+            <a:outerShdw sx="100000" sy="100000" kx="0" ky="0" algn="bl" rotWithShape="0" blurRad="101600" dist="38100" dir="8100000">
+              <a:srgbClr val="000000">
+                <a:alpha val="30000"/>
+              </a:srgbClr>
+            </a:outerShdw>
+          </a:effectLst>
+        </p:spPr>
+      </p:sp>
+      <p:sp>
+        <p:nvSpPr>
+          <p:cNvPr id="6" name="Text 4"/>
+          <p:cNvSpPr/>
+          <p:nvPr/>
+        </p:nvSpPr>
+        <p:spPr>
+          <a:xfrm>
+            <a:off x="502920" y="1143000"/>
+            <a:ext cx="3886200" cy="1462800"/>
+          </a:xfrm>
+          <a:prstGeom prst="rect">
+            <a:avLst/>
+          </a:prstGeom>
+          <a:noFill/>
+          <a:ln/>
+        </p:spPr>
+        <p:txBody>
+          <a:bodyPr wrap="square" lIns="91440" tIns="45720" rIns="91440" bIns="45720" rtlCol="0" anchor="t"/>
+          <a:lstStyle/>
+          <a:p>
+            <a:pPr indent="0" marL="0">
+              <a:buNone/>
+            </a:pPr>
+            <a:r>
+              <a:rPr lang="en-US" sz="1100" b="1" dirty="0">
+                <a:solidFill>
+                  <a:srgbClr val="F5A623"/>
+                </a:solidFill>
+              </a:rPr>
+              <a:t>Firma individual (SHA-3, TSW, w=2)</a:t>
+            </a:r>
+          </a:p>
+          <a:p>
+            <a:pPr indent="0" marL="0">
+              <a:buNone/>
+            </a:pPr>
+            <a:r>
+              <a:rPr lang="en-US" sz="400" dirty="0">
+                <a:solidFill>
+                  <a:srgbClr val="080E1A"/>
+                </a:solidFill>
+              </a:rPr>
+              <a:t xml:space="preserve"> </a:t>
+            </a:r>
+          </a:p>
+          <a:p>
+            <a:pPr indent="0" marL="0">
+              <a:buNone/>
+            </a:pPr>
+            <a:r>
+              <a:rPr lang="en-US" sz="1000" b="1" dirty="0">
+                <a:solidFill>
+                  <a:srgbClr val="BFDBFE"/>
+                </a:solidFill>
+              </a:rPr>
+              <a:t xml:space="preserve">Tamaño de firma:  </a:t>
+            </a:r>
+            <a:r>
+              <a:rPr lang="en-US" sz="1000" dirty="0">
+                <a:solidFill>
+                  <a:srgbClr val="F5A623"/>
+                </a:solidFill>
+              </a:rPr>
+              <a:t>~2,22 KiB</a:t>
+            </a:r>
+          </a:p>
+          <a:p>
+            <a:pPr indent="0" marL="0">
+              <a:buNone/>
+            </a:pPr>
+            <a:r>
+              <a:rPr lang="en-US" sz="1000" b="1" dirty="0">
+                <a:solidFill>
+                  <a:srgbClr val="BFDBFE"/>
+                </a:solidFill>
+              </a:rPr>
+              <a:t xml:space="preserve">Gen. de claves:  </a:t>
+            </a:r>
+            <a:r>
+              <a:rPr lang="en-US" sz="1000" dirty="0">
+                <a:solidFill>
+                  <a:srgbClr val="BFDBFE"/>
+                </a:solidFill>
+              </a:rPr>
+              <a:t>~16 segundos</a:t>
+            </a:r>
+          </a:p>
+          <a:p>
+            <a:pPr indent="0" marL="0">
+              <a:buNone/>
+            </a:pPr>
+            <a:r>
+              <a:rPr lang="en-US" sz="1000" b="1" dirty="0">
+                <a:solidFill>
+                  <a:srgbClr val="BFDBFE"/>
+                </a:solidFill>
+              </a:rPr>
+              <a:t xml:space="preserve">Tiempo de firma:  </a:t>
+            </a:r>
+            <a:r>
+              <a:rPr lang="en-US" sz="1000" dirty="0">
+                <a:solidFill>
+                  <a:srgbClr val="BFDBFE"/>
+                </a:solidFill>
+              </a:rPr>
+              <a:t>~55 µs</a:t>
+            </a:r>
+          </a:p>
+          <a:p>
+            <a:pPr indent="0" marL="0">
+              <a:buNone/>
+            </a:pPr>
+            <a:r>
+              <a:rPr lang="en-US" sz="1000" b="1" dirty="0">
+                <a:solidFill>
+                  <a:srgbClr val="BFDBFE"/>
+                </a:solidFill>
+              </a:rPr>
+              <a:t xml:space="preserve">Verificación:  </a:t>
+            </a:r>
+            <a:r>
+              <a:rPr lang="en-US" sz="1000" dirty="0">
+                <a:solidFill>
+                  <a:srgbClr val="BFDBFE"/>
+                </a:solidFill>
+              </a:rPr>
+              <a:t>~26 µs (~259 hashes)</a:t>
+            </a:r>
+          </a:p>
+        </p:txBody>
+      </p:sp>
+      <p:sp>
+        <p:nvSpPr>
+          <p:cNvPr id="7" name="Shape 5"/>
+          <p:cNvSpPr/>
+          <p:nvPr/>
+        </p:nvSpPr>
+        <p:spPr>
+          <a:xfrm>
+            <a:off x="4663440" y="1097280"/>
+            <a:ext cx="4114800" cy="1554480"/>
+          </a:xfrm>
+          <a:prstGeom prst="rect">
+            <a:avLst/>
+          </a:prstGeom>
+          <a:solidFill>
+            <a:srgbClr val="0F1E3D"/>
+          </a:solidFill>
+          <a:ln w="19050">
+            <a:solidFill>
+              <a:srgbClr val="3B82F6"/>
+            </a:solidFill>
+            <a:prstDash val="solid"/>
+          </a:ln>
+          <a:effectLst>
+            <a:outerShdw sx="100000" sy="100000" kx="0" ky="0" algn="bl" rotWithShape="0" blurRad="101600" dist="38100" dir="8100000">
+              <a:srgbClr val="000000">
+                <a:alpha val="30000"/>
+              </a:srgbClr>
+            </a:outerShdw>
+          </a:effectLst>
+        </p:spPr>
+      </p:sp>
+      <p:sp>
+        <p:nvSpPr>
+          <p:cNvPr id="8" name="Text 6"/>
+          <p:cNvSpPr/>
+          <p:nvPr/>
+        </p:nvSpPr>
+        <p:spPr>
+          <a:xfrm>
+            <a:off x="4800600" y="1143000"/>
+            <a:ext cx="3886200" cy="1462800"/>
+          </a:xfrm>
+          <a:prstGeom prst="rect">
+            <a:avLst/>
+          </a:prstGeom>
+          <a:noFill/>
+          <a:ln/>
+        </p:spPr>
+        <p:txBody>
+          <a:bodyPr wrap="square" lIns="91440" tIns="45720" rIns="91440" bIns="45720" rtlCol="0" anchor="t"/>
+          <a:lstStyle/>
+          <a:p>
+            <a:pPr indent="0" marL="0">
+              <a:buNone/>
+            </a:pPr>
+            <a:r>
+              <a:rPr lang="en-US" sz="1100" b="1" dirty="0">
+                <a:solidFill>
+                  <a:srgbClr val="3B82F6"/>
+                </a:solidFill>
+              </a:rPr>
+              <a:t>Agregación (con Poseidon2)</a:t>
+            </a:r>
+          </a:p>
+          <a:p>
+            <a:pPr indent="0" marL="0">
+              <a:buNone/>
+            </a:pPr>
+            <a:r>
+              <a:rPr lang="en-US" sz="400" dirty="0">
+                <a:solidFill>
+                  <a:srgbClr val="080E1A"/>
+                </a:solidFill>
+              </a:rPr>
+              <a:t xml:space="preserve"> </a:t>
+            </a:r>
+          </a:p>
+          <a:p>
+            <a:pPr indent="0" marL="0">
+              <a:buNone/>
+            </a:pPr>
+            <a:r>
+              <a:rPr lang="en-US" sz="1000" b="1" dirty="0">
+                <a:solidFill>
+                  <a:srgbClr val="BFDBFE"/>
+                </a:solidFill>
+              </a:rPr>
+              <a:t xml:space="preserve">Firmas/seg:  </a:t>
+            </a:r>
+            <a:r>
+              <a:rPr lang="en-US" sz="1000" dirty="0">
+                <a:solidFill>
+                  <a:srgbClr val="3B82F6"/>
+                </a:solidFill>
+              </a:rPr>
+              <a:t>~10.000</a:t>
+            </a:r>
+          </a:p>
+          <a:p>
+            <a:pPr indent="0" marL="0">
+              <a:buNone/>
+            </a:pPr>
+            <a:r>
+              <a:rPr lang="en-US" sz="1000" b="1" dirty="0">
+                <a:solidFill>
+                  <a:srgbClr val="BFDBFE"/>
+                </a:solidFill>
+              </a:rPr>
+              <a:t xml:space="preserve">Plonky3/FRI:  </a:t>
+            </a:r>
+            <a:r>
+              <a:rPr lang="en-US" sz="1000" dirty="0">
+                <a:solidFill>
+                  <a:srgbClr val="BFDBFE"/>
+                </a:solidFill>
+              </a:rPr>
+              <a:t>2-3 MB</a:t>
+            </a:r>
+          </a:p>
+          <a:p>
+            <a:pPr indent="0" marL="0">
+              <a:buNone/>
+            </a:pPr>
+            <a:r>
+              <a:rPr lang="en-US" sz="1000" b="1" dirty="0">
+                <a:solidFill>
+                  <a:srgbClr val="BFDBFE"/>
+                </a:solidFill>
+              </a:rPr>
+              <a:t xml:space="preserve">STIR/WHIR:  </a:t>
+            </a:r>
+            <a:r>
+              <a:rPr lang="en-US" sz="1000" dirty="0">
+                <a:solidFill>
+                  <a:srgbClr val="BFDBFE"/>
+                </a:solidFill>
+              </a:rPr>
+              <a:t>&lt; 1 MB (estimado)</a:t>
+            </a:r>
+          </a:p>
+          <a:p>
+            <a:pPr indent="0" marL="0">
+              <a:buNone/>
+            </a:pPr>
+            <a:r>
+              <a:rPr lang="en-US" sz="400" dirty="0">
+                <a:solidFill>
+                  <a:srgbClr val="080E1A"/>
+                </a:solidFill>
+              </a:rPr>
+              <a:t xml:space="preserve"> </a:t>
+            </a:r>
+          </a:p>
+          <a:p>
+            <a:pPr indent="0" marL="0">
+              <a:buNone/>
+            </a:pPr>
+            <a:r>
+              <a:rPr lang="en-US" sz="850" i="1" dirty="0">
+                <a:solidFill>
+                  <a:srgbClr val="94A3B8"/>
+                </a:solidFill>
+              </a:rPr>
+              <a:t>Poseidon2: ~10x más lento en CPU que SHA-3 pero mucho más eficiente dentro del circuito SNARK.</a:t>
+            </a:r>
+          </a:p>
+        </p:txBody>
+      </p:sp>
+      <p:sp>
+        <p:nvSpPr>
+          <p:cNvPr id="9" name="Shape 7"/>
+          <p:cNvSpPr/>
+          <p:nvPr/>
+        </p:nvSpPr>
+        <p:spPr>
+          <a:xfrm>
+            <a:off x="365760" y="2834640"/>
+            <a:ext cx="8412480" cy="1005840"/>
+          </a:xfrm>
+          <a:prstGeom prst="rect">
+            <a:avLst/>
+          </a:prstGeom>
+          <a:solidFill>
+            <a:srgbClr val="0F1E3D"/>
+          </a:solidFill>
+          <a:ln w="19050">
+            <a:solidFill>
+              <a:srgbClr val="10B981"/>
+            </a:solidFill>
+            <a:prstDash val="solid"/>
+          </a:ln>
+          <a:effectLst>
+            <a:outerShdw sx="100000" sy="100000" kx="0" ky="0" algn="bl" rotWithShape="0" blurRad="101600" dist="38100" dir="8100000">
+              <a:srgbClr val="000000">
+                <a:alpha val="30000"/>
+              </a:srgbClr>
+            </a:outerShdw>
+          </a:effectLst>
+        </p:spPr>
+      </p:sp>
+      <p:sp>
+        <p:nvSpPr>
+          <p:cNvPr id="10" name="Text 8"/>
+          <p:cNvSpPr/>
+          <p:nvPr/>
+        </p:nvSpPr>
+        <p:spPr>
+          <a:xfrm>
+            <a:off x="502920" y="2880360"/>
+            <a:ext cx="8138160" cy="914400"/>
+          </a:xfrm>
+          <a:prstGeom prst="rect">
+            <a:avLst/>
+          </a:prstGeom>
+          <a:noFill/>
+          <a:ln/>
+        </p:spPr>
+        <p:txBody>
+          <a:bodyPr wrap="square" lIns="91440" tIns="45720" rIns="91440" bIns="45720" rtlCol="0" anchor="t"/>
+          <a:lstStyle/>
+          <a:p>
+            <a:pPr indent="0" marL="0">
+              <a:buNone/>
+            </a:pPr>
+            <a:r>
+              <a:rPr lang="en-US" sz="1050" b="1" dirty="0">
+                <a:solidFill>
+                  <a:srgbClr val="10B981"/>
+                </a:solidFill>
+              </a:rPr>
+              <a:t>Comparación con otros esquemas</a:t>
+            </a:r>
+          </a:p>
+          <a:p>
+            <a:pPr indent="0" marL="0">
+              <a:buNone/>
+            </a:pPr>
+            <a:r>
+              <a:rPr lang="en-US" sz="300" dirty="0">
+                <a:solidFill>
+                  <a:srgbClr val="080E1A"/>
+                </a:solidFill>
+              </a:rPr>
+              <a:t xml:space="preserve"> </a:t>
+            </a:r>
+          </a:p>
+          <a:p>
+            <a:pPr indent="0" marL="0">
+              <a:buNone/>
+            </a:pPr>
+            <a:r>
+              <a:rPr lang="en-US" sz="950" b="1" dirty="0">
+                <a:solidFill>
+                  <a:srgbClr val="F5A623"/>
+                </a:solidFill>
+              </a:rPr>
+              <a:t xml:space="preserve">Este paper          </a:t>
+            </a:r>
+            <a:r>
+              <a:rPr lang="en-US" sz="950" dirty="0">
+                <a:solidFill>
+                  <a:srgbClr val="10B981"/>
+                </a:solidFill>
+              </a:rPr>
+              <a:t xml:space="preserve">✅ Agrega     </a:t>
+            </a:r>
+            <a:r>
+              <a:rPr lang="en-US" sz="950" dirty="0">
+                <a:solidFill>
+                  <a:srgbClr val="BFDBFE"/>
+                </a:solidFill>
+              </a:rPr>
+              <a:t>~1-4 KiB</a:t>
+            </a:r>
+          </a:p>
+          <a:p>
+            <a:pPr indent="0" marL="0">
+              <a:buNone/>
+            </a:pPr>
+            <a:r>
+              <a:rPr lang="en-US" sz="950" dirty="0">
+                <a:solidFill>
+                  <a:srgbClr val="BFDBFE"/>
+                </a:solidFill>
+              </a:rPr>
+              <a:t>Khaburzaniya       ✅ Agrega     ~8 KiB</a:t>
+            </a:r>
+          </a:p>
+          <a:p>
+            <a:pPr indent="0" marL="0">
+              <a:buNone/>
+            </a:pPr>
+            <a:r>
+              <a:rPr lang="en-US" sz="950" dirty="0">
+                <a:solidFill>
+                  <a:srgbClr val="BFDBFE"/>
+                </a:solidFill>
+              </a:rPr>
+              <a:t>Squirrel/Chipmunk  ✅ Agrega     &gt;32 KiB</a:t>
+            </a:r>
+          </a:p>
+          <a:p>
+            <a:pPr indent="0" marL="0">
+              <a:buNone/>
+            </a:pPr>
+            <a:r>
+              <a:rPr lang="en-US" sz="950" dirty="0">
+                <a:solidFill>
+                  <a:srgbClr val="BFDBFE"/>
+                </a:solidFill>
+              </a:rPr>
+              <a:t xml:space="preserve">SPHINCS+              </a:t>
+            </a:r>
+            <a:r>
+              <a:rPr lang="en-US" sz="950" dirty="0">
+                <a:solidFill>
+                  <a:srgbClr val="EF4444"/>
+                </a:solidFill>
+              </a:rPr>
+              <a:t xml:space="preserve">❌ No agrega  </a:t>
+            </a:r>
+            <a:r>
+              <a:rPr lang="en-US" sz="950" dirty="0">
+                <a:solidFill>
+                  <a:srgbClr val="BFDBFE"/>
+                </a:solidFill>
+              </a:rPr>
+              <a:t>~8-50 KiB</a:t>
+            </a:r>
+          </a:p>
+        </p:txBody>
+      </p:sp>
+      <p:sp>
+        <p:nvSpPr>
+          <p:cNvPr id="11" name="Shape 9"/>
+          <p:cNvSpPr/>
+          <p:nvPr/>
+        </p:nvSpPr>
+        <p:spPr>
+          <a:xfrm>
+            <a:off x="365760" y="4023360"/>
+            <a:ext cx="8412480" cy="548640"/>
+          </a:xfrm>
+          <a:prstGeom prst="rect">
+            <a:avLst/>
+          </a:prstGeom>
+          <a:solidFill>
+            <a:srgbClr val="10B981">
+              <a:alpha val="15000"/>
+            </a:srgbClr>
+          </a:solidFill>
+          <a:ln w="19050">
+            <a:solidFill>
+              <a:srgbClr val="10B981"/>
+            </a:solidFill>
+            <a:prstDash val="solid"/>
+          </a:ln>
+        </p:spPr>
+      </p:sp>
+      <p:sp>
+        <p:nvSpPr>
+          <p:cNvPr id="12" name="Text 10"/>
+          <p:cNvSpPr/>
+          <p:nvPr/>
+        </p:nvSpPr>
+        <p:spPr>
+          <a:xfrm>
+            <a:off x="502920" y="4023360"/>
+            <a:ext cx="8138160" cy="548640"/>
+          </a:xfrm>
+          <a:prstGeom prst="rect">
+            <a:avLst/>
+          </a:prstGeom>
+          <a:noFill/>
+          <a:ln/>
+        </p:spPr>
+        <p:txBody>
+          <a:bodyPr wrap="square" lIns="91440" tIns="45720" rIns="91440" bIns="45720" rtlCol="0" anchor="ctr"/>
+          <a:lstStyle/>
+          <a:p>
+            <a:pPr indent="0" marL="0">
+              <a:buNone/>
+            </a:pPr>
+            <a:r>
+              <a:rPr lang="en-US" sz="1000" dirty="0">
+                <a:solidFill>
+                  <a:srgbClr val="10B981"/>
+                </a:solidFill>
+              </a:rPr>
+              <a:t>✅  Este esquema tiene las firmas individuales más pequeñas de todos los que soportan agregación. Es la propuesta más eficiente para proof-of-stake post-cuántico a la fecha.</a:t>
+            </a:r>
+          </a:p>
+        </p:txBody>
+      </p:sp>
+    </p:spTree>
+  </p:cSld>
+  <p:clrMapOvr>
+    <a:masterClrMapping/>
+  </p:clrMapOvr>
+</p:sld>
+</file>
+
 <file path=ppt/slides/slide3.xml><?xml version="1.0" encoding="utf-8"?>
 <p:sld xmlns:a="http://schemas.openxmlformats.org/drawingml/2006/main" xmlns:r="http://schemas.openxmlformats.org/officeDocument/2006/relationships" xmlns:p="http://schemas.openxmlformats.org/presentationml/2006/main">
   <p:cSld name="Slide 3">
@@ -15838,6 +19182,70 @@
               <a:t>(publicada)</a:t>
             </a:r>
             <a:endParaRPr lang="en-US" sz="850" dirty="0"/>
+          </a:p>
+        </p:txBody>
+      </p:sp>
+      <p:sp>
+        <p:nvSpPr>
+          <p:cNvPr id="99" name="RefBox"/>
+          <p:cNvSpPr/>
+          <p:nvPr/>
+        </p:nvSpPr>
+        <p:spPr>
+          <a:xfrm>
+            <a:off x="365760" y="4800600"/>
+            <a:ext cx="8412480" cy="274320"/>
+          </a:xfrm>
+          <a:prstGeom prst="rect">
+            <a:avLst/>
+          </a:prstGeom>
+          <a:solidFill>
+            <a:srgbClr val="F5A623">
+              <a:alpha val="12000"/>
+            </a:srgbClr>
+          </a:solidFill>
+          <a:ln w="12700">
+            <a:solidFill>
+              <a:srgbClr val="F5A623">
+                <a:alpha val="40000"/>
+              </a:srgbClr>
+            </a:solidFill>
+            <a:prstDash val="solid"/>
+          </a:ln>
+        </p:spPr>
+      </p:sp>
+      <p:sp>
+        <p:nvSpPr>
+          <p:cNvPr id="100" name="RefText"/>
+          <p:cNvSpPr/>
+          <p:nvPr/>
+        </p:nvSpPr>
+        <p:spPr>
+          <a:xfrm>
+            <a:off x="502920" y="4800600"/>
+            <a:ext cx="8138160" cy="274320"/>
+          </a:xfrm>
+          <a:prstGeom prst="rect">
+            <a:avLst/>
+          </a:prstGeom>
+          <a:noFill/>
+          <a:ln/>
+        </p:spPr>
+        <p:txBody>
+          <a:bodyPr wrap="square" lIns="91440" tIns="0" rIns="91440" bIns="0" rtlCol="0" anchor="ctr"/>
+          <a:lstStyle/>
+          <a:p>
+            <a:pPr indent="0" marL="0">
+              <a:buNone/>
+            </a:pPr>
+            <a:r>
+              <a:rPr lang="en-US" sz="900" i="1" dirty="0">
+                <a:solidFill>
+                  <a:srgbClr val="F5A623"/>
+                </a:solidFill>
+              </a:rPr>
+              <a:t>➡  Ver slide 22: Target Sum Winternitz (TSW) — la variante optimizada para circuitos SNARK</a:t>
+            </a:r>
           </a:p>
         </p:txBody>
       </p:sp>

</xml_diff>

<commit_message>
Add cross-references to XMSS posta PPT and create fused version
- XMSS_Post_Cuantica_posta.pptx: added bidirectional cross-references
  between old slides (4, 15, 17, 18) and new slides (19-23)
- XMSS_Post_Cuantica_fusionada.pptx: new 19-slide version where content
  from the 5 new slides is integrated directly into the original slides
  (Winternitz→TSW, ECDSA comparison→paper results, Lean Ethereum→pqSNARK,
  Los 3 pilares→Random Oracle Paradox, Mundo real→TSW params)

Co-Authored-By: Claude Opus 4.6 <noreply@anthropic.com>
</commit_message>
<xml_diff>
--- a/XMSS_Post_Cuantica_posta.pptx
+++ b/XMSS_Post_Cuantica_posta.pptx
@@ -13844,6 +13844,70 @@
           </a:p>
         </p:txBody>
       </p:sp>
+      <p:sp>
+        <p:nvSpPr>
+          <p:cNvPr id="97" name="RefBox2"/>
+          <p:cNvSpPr/>
+          <p:nvPr/>
+        </p:nvSpPr>
+        <p:spPr>
+          <a:xfrm>
+            <a:off x="365760" y="4617720"/>
+            <a:ext cx="8412480" cy="274320"/>
+          </a:xfrm>
+          <a:prstGeom prst="rect">
+            <a:avLst/>
+          </a:prstGeom>
+          <a:solidFill>
+            <a:srgbClr val="94A3B8">
+              <a:alpha val="10000"/>
+            </a:srgbClr>
+          </a:solidFill>
+          <a:ln w="9525">
+            <a:solidFill>
+              <a:srgbClr val="94A3B8">
+                <a:alpha val="30000"/>
+              </a:srgbClr>
+            </a:solidFill>
+            <a:prstDash val="solid"/>
+          </a:ln>
+        </p:spPr>
+      </p:sp>
+      <p:sp>
+        <p:nvSpPr>
+          <p:cNvPr id="98" name="RefText2"/>
+          <p:cNvSpPr/>
+          <p:nvPr/>
+        </p:nvSpPr>
+        <p:spPr>
+          <a:xfrm>
+            <a:off x="502920" y="4617720"/>
+            <a:ext cx="8138160" cy="274320"/>
+          </a:xfrm>
+          <a:prstGeom prst="rect">
+            <a:avLst/>
+          </a:prstGeom>
+          <a:noFill/>
+          <a:ln/>
+        </p:spPr>
+        <p:txBody>
+          <a:bodyPr wrap="square" lIns="91440" tIns="0" rIns="91440" bIns="0" rtlCol="0" anchor="ctr"/>
+          <a:lstStyle/>
+          <a:p>
+            <a:pPr indent="0" marL="0">
+              <a:buNone/>
+            </a:pPr>
+            <a:r>
+              <a:rPr lang="en-US" sz="850" i="1" dirty="0">
+                <a:solidFill>
+                  <a:srgbClr val="94A3B8"/>
+                </a:solidFill>
+              </a:rPr>
+              <a:t>←  Contexto previo: slide 17 (ECDSA vs XMSS — tamaño ~2-3 KB) y slide 18 (Lean Ethereum — reemplazo de BLS)</a:t>
+            </a:r>
+          </a:p>
+        </p:txBody>
+      </p:sp>
     </p:spTree>
   </p:cSld>
   <p:clrMapOvr>
@@ -15096,6 +15160,70 @@
           </a:p>
         </p:txBody>
       </p:sp>
+      <p:sp>
+        <p:nvSpPr>
+          <p:cNvPr id="97" name="RefBox2"/>
+          <p:cNvSpPr/>
+          <p:nvPr/>
+        </p:nvSpPr>
+        <p:spPr>
+          <a:xfrm>
+            <a:off x="365760" y="4617720"/>
+            <a:ext cx="8412480" cy="274320"/>
+          </a:xfrm>
+          <a:prstGeom prst="rect">
+            <a:avLst/>
+          </a:prstGeom>
+          <a:solidFill>
+            <a:srgbClr val="94A3B8">
+              <a:alpha val="10000"/>
+            </a:srgbClr>
+          </a:solidFill>
+          <a:ln w="9525">
+            <a:solidFill>
+              <a:srgbClr val="94A3B8">
+                <a:alpha val="30000"/>
+              </a:srgbClr>
+            </a:solidFill>
+            <a:prstDash val="solid"/>
+          </a:ln>
+        </p:spPr>
+      </p:sp>
+      <p:sp>
+        <p:nvSpPr>
+          <p:cNvPr id="98" name="RefText2"/>
+          <p:cNvSpPr/>
+          <p:nvPr/>
+        </p:nvSpPr>
+        <p:spPr>
+          <a:xfrm>
+            <a:off x="502920" y="4617720"/>
+            <a:ext cx="8138160" cy="274320"/>
+          </a:xfrm>
+          <a:prstGeom prst="rect">
+            <a:avLst/>
+          </a:prstGeom>
+          <a:noFill/>
+          <a:ln/>
+        </p:spPr>
+        <p:txBody>
+          <a:bodyPr wrap="square" lIns="91440" tIns="0" rIns="91440" bIns="0" rtlCol="0" anchor="ctr"/>
+          <a:lstStyle/>
+          <a:p>
+            <a:pPr indent="0" marL="0">
+              <a:buNone/>
+            </a:pPr>
+            <a:r>
+              <a:rPr lang="en-US" sz="850" i="1" dirty="0">
+                <a:solidFill>
+                  <a:srgbClr val="94A3B8"/>
+                </a:solidFill>
+              </a:rPr>
+              <a:t>←  Contexto previo: slide 3 (XMSS — Los 3 pilares: la seguridad se basa en funciones de hash)</a:t>
+            </a:r>
+          </a:p>
+        </p:txBody>
+      </p:sp>
     </p:spTree>
   </p:cSld>
   <p:clrMapOvr>
@@ -15820,6 +15948,70 @@
           </a:p>
         </p:txBody>
       </p:sp>
+      <p:sp>
+        <p:nvSpPr>
+          <p:cNvPr id="97" name="RefBox2"/>
+          <p:cNvSpPr/>
+          <p:nvPr/>
+        </p:nvSpPr>
+        <p:spPr>
+          <a:xfrm>
+            <a:off x="365760" y="4617720"/>
+            <a:ext cx="8412480" cy="274320"/>
+          </a:xfrm>
+          <a:prstGeom prst="rect">
+            <a:avLst/>
+          </a:prstGeom>
+          <a:solidFill>
+            <a:srgbClr val="94A3B8">
+              <a:alpha val="10000"/>
+            </a:srgbClr>
+          </a:solidFill>
+          <a:ln w="9525">
+            <a:solidFill>
+              <a:srgbClr val="94A3B8">
+                <a:alpha val="30000"/>
+              </a:srgbClr>
+            </a:solidFill>
+            <a:prstDash val="solid"/>
+          </a:ln>
+        </p:spPr>
+      </p:sp>
+      <p:sp>
+        <p:nvSpPr>
+          <p:cNvPr id="98" name="RefText2"/>
+          <p:cNvSpPr/>
+          <p:nvPr/>
+        </p:nvSpPr>
+        <p:spPr>
+          <a:xfrm>
+            <a:off x="502920" y="4617720"/>
+            <a:ext cx="8138160" cy="274320"/>
+          </a:xfrm>
+          <a:prstGeom prst="rect">
+            <a:avLst/>
+          </a:prstGeom>
+          <a:noFill/>
+          <a:ln/>
+        </p:spPr>
+        <p:txBody>
+          <a:bodyPr wrap="square" lIns="91440" tIns="0" rIns="91440" bIns="0" rtlCol="0" anchor="ctr"/>
+          <a:lstStyle/>
+          <a:p>
+            <a:pPr indent="0" marL="0">
+              <a:buNone/>
+            </a:pPr>
+            <a:r>
+              <a:rPr lang="en-US" sz="850" i="1" dirty="0">
+                <a:solidFill>
+                  <a:srgbClr val="94A3B8"/>
+                </a:solidFill>
+              </a:rPr>
+              <a:t>←  Contexto previo: slides 4 y 11-14 (Winternitz OTS clásico — cadenas de hash, firma y verificación paso a paso)</a:t>
+            </a:r>
+          </a:p>
+        </p:txBody>
+      </p:sp>
     </p:spTree>
   </p:cSld>
   <p:clrMapOvr>
@@ -16505,6 +16697,70 @@
                 </a:solidFill>
               </a:rPr>
               <a:t>✅  Este esquema tiene las firmas individuales más pequeñas de todos los que soportan agregación. Es la propuesta más eficiente para proof-of-stake post-cuántico a la fecha.</a:t>
+            </a:r>
+          </a:p>
+        </p:txBody>
+      </p:sp>
+      <p:sp>
+        <p:nvSpPr>
+          <p:cNvPr id="97" name="RefBox2"/>
+          <p:cNvSpPr/>
+          <p:nvPr/>
+        </p:nvSpPr>
+        <p:spPr>
+          <a:xfrm>
+            <a:off x="365760" y="4617720"/>
+            <a:ext cx="8412480" cy="274320"/>
+          </a:xfrm>
+          <a:prstGeom prst="rect">
+            <a:avLst/>
+          </a:prstGeom>
+          <a:solidFill>
+            <a:srgbClr val="94A3B8">
+              <a:alpha val="10000"/>
+            </a:srgbClr>
+          </a:solidFill>
+          <a:ln w="9525">
+            <a:solidFill>
+              <a:srgbClr val="94A3B8">
+                <a:alpha val="30000"/>
+              </a:srgbClr>
+            </a:solidFill>
+            <a:prstDash val="solid"/>
+          </a:ln>
+        </p:spPr>
+      </p:sp>
+      <p:sp>
+        <p:nvSpPr>
+          <p:cNvPr id="98" name="RefText2"/>
+          <p:cNvSpPr/>
+          <p:nvPr/>
+        </p:nvSpPr>
+        <p:spPr>
+          <a:xfrm>
+            <a:off x="502920" y="4617720"/>
+            <a:ext cx="8138160" cy="274320"/>
+          </a:xfrm>
+          <a:prstGeom prst="rect">
+            <a:avLst/>
+          </a:prstGeom>
+          <a:noFill/>
+          <a:ln/>
+        </p:spPr>
+        <p:txBody>
+          <a:bodyPr wrap="square" lIns="91440" tIns="0" rIns="91440" bIns="0" rtlCol="0" anchor="ctr"/>
+          <a:lstStyle/>
+          <a:p>
+            <a:pPr indent="0" marL="0">
+              <a:buNone/>
+            </a:pPr>
+            <a:r>
+              <a:rPr lang="en-US" sz="850" i="1" dirty="0">
+                <a:solidFill>
+                  <a:srgbClr val="94A3B8"/>
+                </a:solidFill>
+              </a:rPr>
+              <a:t>←  Contexto previo: slide 17 (ECDSA vs XMSS — firma ~2-3 KB vs ~64 bytes, aquí los números exactos del paper)</a:t>
             </a:r>
           </a:p>
         </p:txBody>

</xml_diff>